<commit_message>
PAF 26.4 v2.1.0 — observability + two-plane monitoring, deck monitoring slides; relocate hooks to settings fragment for upload-clean frontmatter
</commit_message>
<xml_diff>
--- a/deliverables/PAF_Factory_Deliverables.pptx
+++ b/deliverables/PAF_Factory_Deliverables.pptx
@@ -12,9 +12,10 @@
     <p:sldId id="260" r:id="rId6"/>
     <p:sldId id="261" r:id="rId7"/>
     <p:sldId id="262" r:id="rId8"/>
+    <p:sldId id="263" r:id="rId9"/>
   </p:sldIdLst>
   <p:notesMasterIdLst>
-    <p:notesMasterId r:id="rId9"/>
+    <p:notesMasterId r:id="rId10"/>
   </p:notesMasterIdLst>
   <p:sldSz cx="12192000" cy="6858000"/>
   <p:notesSz cx="6858000" cy="12192000"/>
@@ -1078,6 +1079,94 @@
 </p:notes>
 </file>
 
+<file path=ppt/notesSlides/notesSlide8.xml><?xml version="1.0" encoding="utf-8"?>
+<p:notes xmlns:a="http://schemas.openxmlformats.org/drawingml/2006/main" xmlns:r="http://schemas.openxmlformats.org/officeDocument/2006/relationships" xmlns:p="http://schemas.openxmlformats.org/presentationml/2006/main">
+  <p:cSld>
+    <p:spTree>
+      <p:nvGrpSpPr>
+        <p:cNvPr id="1" name=""/>
+        <p:cNvGrpSpPr/>
+        <p:nvPr/>
+      </p:nvGrpSpPr>
+      <p:grpSpPr>
+        <a:xfrm>
+          <a:off x="0" y="0"/>
+          <a:ext cx="0" cy="0"/>
+          <a:chOff x="0" y="0"/>
+          <a:chExt cx="0" cy="0"/>
+        </a:xfrm>
+      </p:grpSpPr>
+      <p:sp>
+        <p:nvSpPr>
+          <p:cNvPr id="2" name="Slide Image Placeholder 1"/>
+          <p:cNvSpPr>
+            <a:spLocks noGrp="1" noRot="1" noChangeAspect="1"/>
+          </p:cNvSpPr>
+          <p:nvPr>
+            <p:ph type="sldImg"/>
+          </p:nvPr>
+        </p:nvSpPr>
+        <p:spPr/>
+      </p:sp>
+      <p:sp>
+        <p:nvSpPr>
+          <p:cNvPr id="3" name="Notes Placeholder 2"/>
+          <p:cNvSpPr>
+            <a:spLocks noGrp="1"/>
+          </p:cNvSpPr>
+          <p:nvPr>
+            <p:ph type="body" idx="1"/>
+          </p:nvPr>
+        </p:nvSpPr>
+        <p:spPr/>
+        <p:txBody>
+          <a:bodyPr/>
+          <a:lstStyle/>
+          <a:p>
+            <a:r>
+              <a:rPr lang="en-US" dirty="0"/>
+              <a:t/>
+            </a:r>
+            <a:endParaRPr lang="en-US" dirty="0"/>
+          </a:p>
+        </p:txBody>
+      </p:sp>
+      <p:sp>
+        <p:nvSpPr>
+          <p:cNvPr id="4" name="Slide Number Placeholder 3"/>
+          <p:cNvSpPr>
+            <a:spLocks noGrp="1"/>
+          </p:cNvSpPr>
+          <p:nvPr>
+            <p:ph type="sldNum" sz="quarter" idx="10"/>
+          </p:nvPr>
+        </p:nvSpPr>
+        <p:spPr/>
+        <p:txBody>
+          <a:bodyPr/>
+          <a:lstStyle/>
+          <a:p>
+            <a:fld id="{F7021451-1387-4CA6-816F-3879F97B5CBC}" type="slidenum">
+              <a:rPr lang="en-US"/>
+              <a:t>8</a:t>
+            </a:fld>
+            <a:endParaRPr lang="en-US"/>
+          </a:p>
+        </p:txBody>
+      </p:sp>
+    </p:spTree>
+    <p:extLst>
+      <p:ext uri="{BB962C8B-B14F-4D97-AF65-F5344CB8AC3E}">
+        <p14:creationId xmlns:p14="http://schemas.microsoft.com/office/powerpoint/2010/main" val="1024086991"/>
+      </p:ext>
+    </p:extLst>
+  </p:cSld>
+  <p:clrMapOvr>
+    <a:masterClrMapping/>
+  </p:clrMapOvr>
+</p:notes>
+</file>
+
 <file path=ppt/slideLayouts/slideLayout1.xml><?xml version="1.0" encoding="utf-8"?>
 <p:sldLayout xmlns:a="http://schemas.openxmlformats.org/drawingml/2006/main" xmlns:r="http://schemas.openxmlformats.org/officeDocument/2006/relationships" xmlns:p="http://schemas.openxmlformats.org/presentationml/2006/main" preserve="1">
   <p:cSld name="DEFAULT">
@@ -1628,7 +1717,7 @@
       </p:sp>
       <p:pic>
         <p:nvPicPr>
-          <p:cNvPr id="10" name="Image 0" descr="/Users/mikemiller/.claude/skills/ebs-paf-agent/assets/syntax-logo.png">    </p:cNvPr>
+          <p:cNvPr id="10" name="Image 0" descr="/home/claude/skill-work/assets/syntax-logo.png">    </p:cNvPr>
           <p:cNvPicPr>
             <a:picLocks noChangeAspect="1"/>
           </p:cNvPicPr>
@@ -1881,7 +1970,7 @@
       </p:sp>
       <p:pic>
         <p:nvPicPr>
-          <p:cNvPr id="8" name="Image 0" descr="/Users/mikemiller/.claude/skills/ebs-paf-agent/assets/syntax-logo.png">    </p:cNvPr>
+          <p:cNvPr id="8" name="Image 0" descr="/home/claude/skill-work/assets/syntax-logo.png">    </p:cNvPr>
           <p:cNvPicPr>
             <a:picLocks noChangeAspect="1"/>
           </p:cNvPicPr>
@@ -1905,7 +1994,7 @@
       </p:pic>
       <p:pic>
         <p:nvPicPr>
-          <p:cNvPr id="9" name="Image 1" descr="/Users/mikemiller/.claude/skills/ebs-paf-agent/deliverables/assets/deliverables_map.png">    </p:cNvPr>
+          <p:cNvPr id="9" name="Image 1" descr="/home/claude/skill-work/deliverables/assets/deliverables_map.png">    </p:cNvPr>
           <p:cNvPicPr>
             <a:picLocks noChangeAspect="1"/>
           </p:cNvPicPr>
@@ -2220,7 +2309,7 @@
       </p:sp>
       <p:pic>
         <p:nvPicPr>
-          <p:cNvPr id="8" name="Image 0" descr="/Users/mikemiller/.claude/skills/ebs-paf-agent/assets/syntax-logo.png">    </p:cNvPr>
+          <p:cNvPr id="8" name="Image 0" descr="/home/claude/skill-work/assets/syntax-logo.png">    </p:cNvPr>
           <p:cNvPicPr>
             <a:picLocks noChangeAspect="1"/>
           </p:cNvPicPr>
@@ -3552,13 +3641,17 @@
         </p:nvSpPr>
         <p:spPr>
           <a:xfrm>
-            <a:off x="457200" y="6400800"/>
-            <a:ext cx="11277295" cy="0"/>
-          </a:xfrm>
-          <a:prstGeom prst="line">
-            <a:avLst/>
-          </a:prstGeom>
-          <a:noFill/>
+            <a:off x="9043416" y="3657600"/>
+            <a:ext cx="2697480" cy="2240280"/>
+          </a:xfrm>
+          <a:prstGeom prst="roundRect">
+            <a:avLst>
+              <a:gd name="adj" fmla="val 3265"/>
+            </a:avLst>
+          </a:prstGeom>
+          <a:solidFill>
+            <a:srgbClr val="F4F7FC"/>
+          </a:solidFill>
           <a:ln w="12700">
             <a:solidFill>
               <a:srgbClr val="DCE4F4"/>
@@ -3569,14 +3662,34 @@
       </p:sp>
       <p:sp>
         <p:nvSpPr>
-          <p:cNvPr id="52" name="Text 49"/>
-          <p:cNvSpPr/>
-          <p:nvPr/>
-        </p:nvSpPr>
-        <p:spPr>
-          <a:xfrm>
-            <a:off x="457200" y="6437376"/>
-            <a:ext cx="7315200" cy="274320"/>
+          <p:cNvPr id="52" name="Shape 49"/>
+          <p:cNvSpPr/>
+          <p:nvPr/>
+        </p:nvSpPr>
+        <p:spPr>
+          <a:xfrm>
+            <a:off x="9043416" y="3657600"/>
+            <a:ext cx="2697480" cy="109728"/>
+          </a:xfrm>
+          <a:prstGeom prst="rect">
+            <a:avLst/>
+          </a:prstGeom>
+          <a:solidFill>
+            <a:srgbClr val="0632A0"/>
+          </a:solidFill>
+          <a:ln/>
+        </p:spPr>
+      </p:sp>
+      <p:sp>
+        <p:nvSpPr>
+          <p:cNvPr id="53" name="Text 50"/>
+          <p:cNvSpPr/>
+          <p:nvPr/>
+        </p:nvSpPr>
+        <p:spPr>
+          <a:xfrm>
+            <a:off x="9208008" y="3877056"/>
+            <a:ext cx="2368296" cy="365760"/>
           </a:xfrm>
           <a:prstGeom prst="rect">
             <a:avLst/>
@@ -3592,14 +3705,176 @@
               <a:buNone/>
             </a:pPr>
             <a:r>
-              <a:rPr lang="en-US" sz="900" dirty="0">
-                <a:solidFill>
-                  <a:srgbClr val="5B6577"/>
+              <a:rPr lang="en-US" sz="1400" b="1" dirty="0">
+                <a:solidFill>
+                  <a:srgbClr val="16203A"/>
+                </a:solidFill>
+                <a:latin typeface="Georgia" pitchFamily="34" charset="0"/>
+                <a:ea typeface="Georgia" pitchFamily="34" charset="-122"/>
+                <a:cs typeface="Georgia" pitchFamily="34" charset="-120"/>
+              </a:rPr>
+              <a:t>Monitoring &amp; obs TDD</a:t>
+            </a:r>
+            <a:endParaRPr lang="en-US" sz="1400" dirty="0"/>
+          </a:p>
+        </p:txBody>
+      </p:sp>
+      <p:sp>
+        <p:nvSpPr>
+          <p:cNvPr id="54" name="Shape 51"/>
+          <p:cNvSpPr/>
+          <p:nvPr/>
+        </p:nvSpPr>
+        <p:spPr>
+          <a:xfrm>
+            <a:off x="9208008" y="4315968"/>
+            <a:ext cx="868680" cy="274320"/>
+          </a:xfrm>
+          <a:prstGeom prst="roundRect">
+            <a:avLst>
+              <a:gd name="adj" fmla="val 50000"/>
+            </a:avLst>
+          </a:prstGeom>
+          <a:solidFill>
+            <a:srgbClr val="0632A0"/>
+          </a:solidFill>
+          <a:ln/>
+        </p:spPr>
+      </p:sp>
+      <p:sp>
+        <p:nvSpPr>
+          <p:cNvPr id="55" name="Text 52"/>
+          <p:cNvSpPr/>
+          <p:nvPr/>
+        </p:nvSpPr>
+        <p:spPr>
+          <a:xfrm>
+            <a:off x="9208008" y="4315968"/>
+            <a:ext cx="868680" cy="274320"/>
+          </a:xfrm>
+          <a:prstGeom prst="rect">
+            <a:avLst/>
+          </a:prstGeom>
+          <a:noFill/>
+          <a:ln/>
+        </p:spPr>
+        <p:txBody>
+          <a:bodyPr wrap="square" rtlCol="0" anchor="ctr"/>
+          <a:lstStyle/>
+          <a:p>
+            <a:pPr algn="ctr" indent="0" marL="0">
+              <a:buNone/>
+            </a:pPr>
+            <a:r>
+              <a:rPr lang="en-US" sz="1100" b="1" dirty="0">
+                <a:solidFill>
+                  <a:srgbClr val="FFFFFF"/>
                 </a:solidFill>
                 <a:latin typeface="Calibri" pitchFamily="34" charset="0"/>
                 <a:ea typeface="Calibri" pitchFamily="34" charset="-122"/>
                 <a:cs typeface="Calibri" pitchFamily="34" charset="-120"/>
               </a:rPr>
+              <a:t>.docx</a:t>
+            </a:r>
+            <a:endParaRPr lang="en-US" sz="1100" dirty="0"/>
+          </a:p>
+        </p:txBody>
+      </p:sp>
+      <p:sp>
+        <p:nvSpPr>
+          <p:cNvPr id="56" name="Text 53"/>
+          <p:cNvSpPr/>
+          <p:nvPr/>
+        </p:nvSpPr>
+        <p:spPr>
+          <a:xfrm>
+            <a:off x="9208008" y="4681728"/>
+            <a:ext cx="2368296" cy="1143000"/>
+          </a:xfrm>
+          <a:prstGeom prst="rect">
+            <a:avLst/>
+          </a:prstGeom>
+          <a:noFill/>
+          <a:ln/>
+        </p:spPr>
+        <p:txBody>
+          <a:bodyPr wrap="square" rtlCol="0" anchor="t"/>
+          <a:lstStyle/>
+          <a:p>
+            <a:pPr indent="0" marL="0">
+              <a:buNone/>
+            </a:pPr>
+            <a:r>
+              <a:rPr lang="en-US" sz="1100" dirty="0">
+                <a:solidFill>
+                  <a:srgbClr val="5B6577"/>
+                </a:solidFill>
+                <a:latin typeface="Calibri" pitchFamily="34" charset="0"/>
+                <a:ea typeface="Calibri" pitchFamily="34" charset="-122"/>
+                <a:cs typeface="Calibri" pitchFamily="34" charset="-120"/>
+              </a:rPr>
+              <a:t>Two-plane supervision design (Plane A traces + Plane B availability) + CxHub data contract. Per-tenancy.</a:t>
+            </a:r>
+            <a:endParaRPr lang="en-US" sz="1100" dirty="0"/>
+          </a:p>
+        </p:txBody>
+      </p:sp>
+      <p:sp>
+        <p:nvSpPr>
+          <p:cNvPr id="57" name="Shape 54"/>
+          <p:cNvSpPr/>
+          <p:nvPr/>
+        </p:nvSpPr>
+        <p:spPr>
+          <a:xfrm>
+            <a:off x="457200" y="6400800"/>
+            <a:ext cx="11277295" cy="0"/>
+          </a:xfrm>
+          <a:prstGeom prst="line">
+            <a:avLst/>
+          </a:prstGeom>
+          <a:noFill/>
+          <a:ln w="12700">
+            <a:solidFill>
+              <a:srgbClr val="DCE4F4"/>
+            </a:solidFill>
+            <a:prstDash val="solid"/>
+          </a:ln>
+        </p:spPr>
+      </p:sp>
+      <p:sp>
+        <p:nvSpPr>
+          <p:cNvPr id="58" name="Text 55"/>
+          <p:cNvSpPr/>
+          <p:nvPr/>
+        </p:nvSpPr>
+        <p:spPr>
+          <a:xfrm>
+            <a:off x="457200" y="6437376"/>
+            <a:ext cx="7315200" cy="274320"/>
+          </a:xfrm>
+          <a:prstGeom prst="rect">
+            <a:avLst/>
+          </a:prstGeom>
+          <a:noFill/>
+          <a:ln/>
+        </p:spPr>
+        <p:txBody>
+          <a:bodyPr wrap="square" rtlCol="0" anchor="ctr"/>
+          <a:lstStyle/>
+          <a:p>
+            <a:pPr indent="0" marL="0">
+              <a:buNone/>
+            </a:pPr>
+            <a:r>
+              <a:rPr lang="en-US" sz="900" dirty="0">
+                <a:solidFill>
+                  <a:srgbClr val="5B6577"/>
+                </a:solidFill>
+                <a:latin typeface="Calibri" pitchFamily="34" charset="0"/>
+                <a:ea typeface="Calibri" pitchFamily="34" charset="-122"/>
+                <a:cs typeface="Calibri" pitchFamily="34" charset="-120"/>
+              </a:rPr>
               <a:t>Syntax Corporation © 2026 · Confidential</a:t>
             </a:r>
             <a:endParaRPr lang="en-US" sz="900" dirty="0"/>
@@ -3608,7 +3883,7 @@
       </p:sp>
       <p:sp>
         <p:nvSpPr>
-          <p:cNvPr id="53" name="Text 50"/>
+          <p:cNvPr id="59" name="Text 56"/>
           <p:cNvSpPr/>
           <p:nvPr/>
         </p:nvSpPr>
@@ -3837,7 +4112,7 @@
       </p:sp>
       <p:pic>
         <p:nvPicPr>
-          <p:cNvPr id="8" name="Image 0" descr="/Users/mikemiller/.claude/skills/ebs-paf-agent/assets/syntax-logo.png">    </p:cNvPr>
+          <p:cNvPr id="8" name="Image 0" descr="/home/claude/skill-work/assets/syntax-logo.png">    </p:cNvPr>
           <p:cNvPicPr>
             <a:picLocks noChangeAspect="1"/>
           </p:cNvPicPr>
@@ -5221,7 +5496,7 @@
                 <a:ea typeface="Georgia" pitchFamily="34" charset="-122"/>
                 <a:cs typeface="Georgia" pitchFamily="34" charset="-120"/>
               </a:rPr>
-              <a:t>Built right</a:t>
+              <a:t>Adult supervision</a:t>
             </a:r>
             <a:endParaRPr lang="en-US" sz="2600" dirty="0"/>
           </a:p>
@@ -5260,7 +5535,7 @@
                 <a:ea typeface="Calibri" pitchFamily="34" charset="-122"/>
                 <a:cs typeface="Calibri" pitchFamily="34" charset="-120"/>
               </a:rPr>
-              <a:t>Why the deliverables are trustworthy</a:t>
+              <a:t>Two-plane monitoring — platform availability + agent observability, one pane</a:t>
             </a:r>
             <a:endParaRPr lang="en-US" sz="1300" dirty="0"/>
           </a:p>
@@ -5268,7 +5543,7 @@
       </p:sp>
       <p:pic>
         <p:nvPicPr>
-          <p:cNvPr id="8" name="Image 0" descr="/Users/mikemiller/.claude/skills/ebs-paf-agent/assets/syntax-logo.png">    </p:cNvPr>
+          <p:cNvPr id="8" name="Image 0" descr="/home/claude/skill-work/assets/syntax-logo.png">    </p:cNvPr>
           <p:cNvPicPr>
             <a:picLocks noChangeAspect="1"/>
           </p:cNvPicPr>
@@ -5298,12 +5573,12 @@
         </p:nvSpPr>
         <p:spPr>
           <a:xfrm>
-            <a:off x="457200" y="1371600"/>
-            <a:ext cx="3703320" cy="4206240"/>
+            <a:off x="457200" y="1234440"/>
+            <a:ext cx="5486400" cy="3246120"/>
           </a:xfrm>
           <a:prstGeom prst="roundRect">
             <a:avLst>
-              <a:gd name="adj" fmla="val 2469"/>
+              <a:gd name="adj" fmla="val 2817"/>
             </a:avLst>
           </a:prstGeom>
           <a:solidFill>
@@ -5325,14 +5600,14 @@
         </p:nvSpPr>
         <p:spPr>
           <a:xfrm>
-            <a:off x="457200" y="1371600"/>
-            <a:ext cx="3703320" cy="146304"/>
-          </a:xfrm>
-          <a:prstGeom prst="rect">
-            <a:avLst/>
-          </a:prstGeom>
-          <a:solidFill>
-            <a:srgbClr val="0632A0"/>
+            <a:off x="457200" y="1234440"/>
+            <a:ext cx="5486400" cy="146304"/>
+          </a:xfrm>
+          <a:prstGeom prst="rect">
+            <a:avLst/>
+          </a:prstGeom>
+          <a:solidFill>
+            <a:srgbClr val="1EB4E6"/>
           </a:solidFill>
           <a:ln/>
         </p:spPr>
@@ -5345,8 +5620,8 @@
         </p:nvSpPr>
         <p:spPr>
           <a:xfrm>
-            <a:off x="685800" y="1691640"/>
-            <a:ext cx="914400" cy="822960"/>
+            <a:off x="713232" y="1481328"/>
+            <a:ext cx="4937760" cy="411480"/>
           </a:xfrm>
           <a:prstGeom prst="rect">
             <a:avLst/>
@@ -5362,17 +5637,17 @@
               <a:buNone/>
             </a:pPr>
             <a:r>
-              <a:rPr lang="en-US" sz="4400" b="1" dirty="0">
-                <a:solidFill>
-                  <a:srgbClr val="0632A0"/>
+              <a:rPr lang="en-US" sz="1800" b="1" dirty="0">
+                <a:solidFill>
+                  <a:srgbClr val="16203A"/>
                 </a:solidFill>
                 <a:latin typeface="Georgia" pitchFamily="34" charset="0"/>
                 <a:ea typeface="Georgia" pitchFamily="34" charset="-122"/>
                 <a:cs typeface="Georgia" pitchFamily="34" charset="-120"/>
               </a:rPr>
-              <a:t>1</a:t>
-            </a:r>
-            <a:endParaRPr lang="en-US" sz="4400" dirty="0"/>
+              <a:t>Plane A · Agent observability</a:t>
+            </a:r>
+            <a:endParaRPr lang="en-US" sz="1800" dirty="0"/>
           </a:p>
         </p:txBody>
       </p:sp>
@@ -5384,8 +5659,8 @@
         </p:nvSpPr>
         <p:spPr>
           <a:xfrm>
-            <a:off x="685800" y="2606040"/>
-            <a:ext cx="3291840" cy="640080"/>
+            <a:off x="713232" y="1883664"/>
+            <a:ext cx="4937760" cy="274320"/>
           </a:xfrm>
           <a:prstGeom prst="rect">
             <a:avLst/>
@@ -5401,56 +5676,102 @@
               <a:buNone/>
             </a:pPr>
             <a:r>
-              <a:rPr lang="en-US" sz="1800" b="1" dirty="0">
-                <a:solidFill>
-                  <a:srgbClr val="16203A"/>
-                </a:solidFill>
-                <a:latin typeface="Georgia" pitchFamily="34" charset="0"/>
-                <a:ea typeface="Georgia" pitchFamily="34" charset="-122"/>
-                <a:cs typeface="Georgia" pitchFamily="34" charset="-120"/>
-              </a:rPr>
-              <a:t>Single source of truth</a:t>
-            </a:r>
-            <a:endParaRPr lang="en-US" sz="1800" dirty="0"/>
-          </a:p>
-        </p:txBody>
-      </p:sp>
-      <p:sp>
-        <p:nvSpPr>
-          <p:cNvPr id="13" name="Text 10"/>
-          <p:cNvSpPr/>
-          <p:nvPr/>
-        </p:nvSpPr>
-        <p:spPr>
-          <a:xfrm>
-            <a:off x="685800" y="3291840"/>
-            <a:ext cx="3246120" cy="2103120"/>
-          </a:xfrm>
-          <a:prstGeom prst="rect">
-            <a:avLst/>
-          </a:prstGeom>
-          <a:noFill/>
-          <a:ln/>
-        </p:spPr>
-        <p:txBody>
-          <a:bodyPr wrap="square" rtlCol="0" anchor="t"/>
-          <a:lstStyle/>
-          <a:p>
-            <a:pPr indent="0" marL="0">
-              <a:buNone/>
-            </a:pPr>
-            <a:r>
-              <a:rPr lang="en-US" sz="1300" dirty="0">
-                <a:solidFill>
-                  <a:srgbClr val="5B6577"/>
+              <a:rPr lang="en-US" sz="1100" b="1" spc="200" kern="0" dirty="0">
+                <a:solidFill>
+                  <a:srgbClr val="1EB4E6"/>
                 </a:solidFill>
                 <a:latin typeface="Calibri" pitchFamily="34" charset="0"/>
                 <a:ea typeface="Calibri" pitchFamily="34" charset="-122"/>
                 <a:cs typeface="Calibri" pitchFamily="34" charset="-120"/>
               </a:rPr>
-              <a:t>Customer files are generated from in-repo markdown + one pricing model. Edit the source, regenerate — deck, SOW, and ROI never disagree.</a:t>
-            </a:r>
-            <a:endParaRPr lang="en-US" sz="1300" dirty="0"/>
+              <a:t>THE DIFFERENTIATOR</a:t>
+            </a:r>
+            <a:endParaRPr lang="en-US" sz="1100" dirty="0"/>
+          </a:p>
+        </p:txBody>
+      </p:sp>
+      <p:sp>
+        <p:nvSpPr>
+          <p:cNvPr id="13" name="Text 10"/>
+          <p:cNvSpPr/>
+          <p:nvPr/>
+        </p:nvSpPr>
+        <p:spPr>
+          <a:xfrm>
+            <a:off x="713232" y="2286000"/>
+            <a:ext cx="4983480" cy="2057400"/>
+          </a:xfrm>
+          <a:prstGeom prst="rect">
+            <a:avLst/>
+          </a:prstGeom>
+          <a:noFill/>
+          <a:ln/>
+        </p:spPr>
+        <p:txBody>
+          <a:bodyPr wrap="square" rtlCol="0" anchor="t"/>
+          <a:lstStyle/>
+          <a:p>
+            <a:pPr marL="177800" indent="-177800">
+              <a:spcAft>
+                <a:spcPts val="800"/>
+              </a:spcAft>
+              <a:buSzPct val="100000"/>
+              <a:buChar char="•"/>
+            </a:pPr>
+            <a:r>
+              <a:rPr lang="en-US" sz="1200" dirty="0">
+                <a:solidFill>
+                  <a:srgbClr val="5B6577"/>
+                </a:solidFill>
+                <a:latin typeface="Calibri" pitchFamily="34" charset="0"/>
+                <a:ea typeface="Calibri" pitchFamily="34" charset="-122"/>
+                <a:cs typeface="Calibri" pitchFamily="34" charset="-120"/>
+              </a:rPr>
+              <a:t>Every run traced — step, tool call, LLM call; latency and cost attributed per run, agent and time window</a:t>
+            </a:r>
+            <a:endParaRPr lang="en-US" sz="1200" dirty="0"/>
+          </a:p>
+          <a:p>
+            <a:pPr marL="177800" indent="-177800">
+              <a:spcAft>
+                <a:spcPts val="800"/>
+              </a:spcAft>
+              <a:buSzPct val="100000"/>
+              <a:buChar char="•"/>
+            </a:pPr>
+            <a:r>
+              <a:rPr lang="en-US" sz="1200" dirty="0">
+                <a:solidFill>
+                  <a:srgbClr val="5B6577"/>
+                </a:solidFill>
+                <a:latin typeface="Calibri" pitchFamily="34" charset="0"/>
+                <a:ea typeface="Calibri" pitchFamily="34" charset="-122"/>
+                <a:cs typeface="Calibri" pitchFamily="34" charset="-120"/>
+              </a:rPr>
+              <a:t>Tool-call success rate flags a degraded MCP server or ERP backend before users feel it</a:t>
+            </a:r>
+            <a:endParaRPr lang="en-US" sz="1200" dirty="0"/>
+          </a:p>
+          <a:p>
+            <a:pPr marL="177800" indent="-177800">
+              <a:spcAft>
+                <a:spcPts val="800"/>
+              </a:spcAft>
+              <a:buSzPct val="100000"/>
+              <a:buChar char="•"/>
+            </a:pPr>
+            <a:r>
+              <a:rPr lang="en-US" sz="1200" dirty="0">
+                <a:solidFill>
+                  <a:srgbClr val="5B6577"/>
+                </a:solidFill>
+                <a:latin typeface="Calibri" pitchFamily="34" charset="0"/>
+                <a:ea typeface="Calibri" pitchFamily="34" charset="-122"/>
+                <a:cs typeface="Calibri" pitchFamily="34" charset="-120"/>
+              </a:rPr>
+              <a:t>Automated evaluators score groundedness and tool-call validity — quality without storing payloads</a:t>
+            </a:r>
+            <a:endParaRPr lang="en-US" sz="1200" dirty="0"/>
           </a:p>
         </p:txBody>
       </p:sp>
@@ -5462,12 +5783,12 @@
         </p:nvSpPr>
         <p:spPr>
           <a:xfrm>
-            <a:off x="4325112" y="1371600"/>
-            <a:ext cx="3703320" cy="4206240"/>
+            <a:off x="6245352" y="1234440"/>
+            <a:ext cx="5486400" cy="3246120"/>
           </a:xfrm>
           <a:prstGeom prst="roundRect">
             <a:avLst>
-              <a:gd name="adj" fmla="val 2469"/>
+              <a:gd name="adj" fmla="val 2817"/>
             </a:avLst>
           </a:prstGeom>
           <a:solidFill>
@@ -5489,8 +5810,8 @@
         </p:nvSpPr>
         <p:spPr>
           <a:xfrm>
-            <a:off x="4325112" y="1371600"/>
-            <a:ext cx="3703320" cy="146304"/>
+            <a:off x="6245352" y="1234440"/>
+            <a:ext cx="5486400" cy="146304"/>
           </a:xfrm>
           <a:prstGeom prst="rect">
             <a:avLst/>
@@ -5509,8 +5830,8 @@
         </p:nvSpPr>
         <p:spPr>
           <a:xfrm>
-            <a:off x="4553712" y="1691640"/>
-            <a:ext cx="914400" cy="822960"/>
+            <a:off x="6501384" y="1481328"/>
+            <a:ext cx="4937760" cy="411480"/>
           </a:xfrm>
           <a:prstGeom prst="rect">
             <a:avLst/>
@@ -5526,17 +5847,17 @@
               <a:buNone/>
             </a:pPr>
             <a:r>
-              <a:rPr lang="en-US" sz="4400" b="1" dirty="0">
-                <a:solidFill>
-                  <a:srgbClr val="3CC85A"/>
+              <a:rPr lang="en-US" sz="1800" b="1" dirty="0">
+                <a:solidFill>
+                  <a:srgbClr val="16203A"/>
                 </a:solidFill>
                 <a:latin typeface="Georgia" pitchFamily="34" charset="0"/>
                 <a:ea typeface="Georgia" pitchFamily="34" charset="-122"/>
                 <a:cs typeface="Georgia" pitchFamily="34" charset="-120"/>
               </a:rPr>
-              <a:t>2</a:t>
-            </a:r>
-            <a:endParaRPr lang="en-US" sz="4400" dirty="0"/>
+              <a:t>Plane B · Platform availability</a:t>
+            </a:r>
+            <a:endParaRPr lang="en-US" sz="1800" dirty="0"/>
           </a:p>
         </p:txBody>
       </p:sp>
@@ -5548,8 +5869,8 @@
         </p:nvSpPr>
         <p:spPr>
           <a:xfrm>
-            <a:off x="4553712" y="2606040"/>
-            <a:ext cx="3291840" cy="640080"/>
+            <a:off x="6501384" y="1883664"/>
+            <a:ext cx="4937760" cy="274320"/>
           </a:xfrm>
           <a:prstGeom prst="rect">
             <a:avLst/>
@@ -5565,56 +5886,102 @@
               <a:buNone/>
             </a:pPr>
             <a:r>
-              <a:rPr lang="en-US" sz="1800" b="1" dirty="0">
-                <a:solidFill>
-                  <a:srgbClr val="16203A"/>
-                </a:solidFill>
-                <a:latin typeface="Georgia" pitchFamily="34" charset="0"/>
-                <a:ea typeface="Georgia" pitchFamily="34" charset="-122"/>
-                <a:cs typeface="Georgia" pitchFamily="34" charset="-120"/>
-              </a:rPr>
-              <a:t>QA-gated</a:t>
-            </a:r>
-            <a:endParaRPr lang="en-US" sz="1800" dirty="0"/>
-          </a:p>
-        </p:txBody>
-      </p:sp>
-      <p:sp>
-        <p:nvSpPr>
-          <p:cNvPr id="18" name="Text 15"/>
-          <p:cNvSpPr/>
-          <p:nvPr/>
-        </p:nvSpPr>
-        <p:spPr>
-          <a:xfrm>
-            <a:off x="4553712" y="3291840"/>
-            <a:ext cx="3246120" cy="2103120"/>
-          </a:xfrm>
-          <a:prstGeom prst="rect">
-            <a:avLst/>
-          </a:prstGeom>
-          <a:noFill/>
-          <a:ln/>
-        </p:spPr>
-        <p:txBody>
-          <a:bodyPr wrap="square" rtlCol="0" anchor="t"/>
-          <a:lstStyle/>
-          <a:p>
-            <a:pPr indent="0" marL="0">
-              <a:buNone/>
-            </a:pPr>
-            <a:r>
-              <a:rPr lang="en-US" sz="1300" dirty="0">
-                <a:solidFill>
-                  <a:srgbClr val="5B6577"/>
+              <a:rPr lang="en-US" sz="1100" b="1" spc="200" kern="0" dirty="0">
+                <a:solidFill>
+                  <a:srgbClr val="3CC85A"/>
                 </a:solidFill>
                 <a:latin typeface="Calibri" pitchFamily="34" charset="0"/>
                 <a:ea typeface="Calibri" pitchFamily="34" charset="-122"/>
                 <a:cs typeface="Calibri" pitchFamily="34" charset="-120"/>
               </a:rPr>
-              <a:t>Nothing is generated until the QA gate is green: hermetic + live + parity tests pass, and the validation gate shows zero unsafe actions.</a:t>
-            </a:r>
-            <a:endParaRPr lang="en-US" sz="1300" dirty="0"/>
+              <a:t>TABLE STAKES</a:t>
+            </a:r>
+            <a:endParaRPr lang="en-US" sz="1100" dirty="0"/>
+          </a:p>
+        </p:txBody>
+      </p:sp>
+      <p:sp>
+        <p:nvSpPr>
+          <p:cNvPr id="18" name="Text 15"/>
+          <p:cNvSpPr/>
+          <p:nvPr/>
+        </p:nvSpPr>
+        <p:spPr>
+          <a:xfrm>
+            <a:off x="6501384" y="2286000"/>
+            <a:ext cx="4983480" cy="2057400"/>
+          </a:xfrm>
+          <a:prstGeom prst="rect">
+            <a:avLst/>
+          </a:prstGeom>
+          <a:noFill/>
+          <a:ln/>
+        </p:spPr>
+        <p:txBody>
+          <a:bodyPr wrap="square" rtlCol="0" anchor="t"/>
+          <a:lstStyle/>
+          <a:p>
+            <a:pPr marL="177800" indent="-177800">
+              <a:spcAft>
+                <a:spcPts val="800"/>
+              </a:spcAft>
+              <a:buSzPct val="100000"/>
+              <a:buChar char="•"/>
+            </a:pPr>
+            <a:r>
+              <a:rPr lang="en-US" sz="1200" dirty="0">
+                <a:solidFill>
+                  <a:srgbClr val="5B6577"/>
+                </a:solidFill>
+                <a:latin typeface="Calibri" pitchFamily="34" charset="0"/>
+                <a:ea typeface="Calibri" pitchFamily="34" charset="-122"/>
+                <a:cs typeface="Calibri" pitchFamily="34" charset="-120"/>
+              </a:rPr>
+              <a:t>Synthetic probes replicate every PAF connection — DB 26ai, model endpoint, MCP, egress</a:t>
+            </a:r>
+            <a:endParaRPr lang="en-US" sz="1200" dirty="0"/>
+          </a:p>
+          <a:p>
+            <a:pPr marL="177800" indent="-177800">
+              <a:spcAft>
+                <a:spcPts val="800"/>
+              </a:spcAft>
+              <a:buSzPct val="100000"/>
+              <a:buChar char="•"/>
+            </a:pPr>
+            <a:r>
+              <a:rPr lang="en-US" sz="1200" dirty="0">
+                <a:solidFill>
+                  <a:srgbClr val="5B6577"/>
+                </a:solidFill>
+                <a:latin typeface="Calibri" pitchFamily="34" charset="0"/>
+                <a:ea typeface="Calibri" pitchFamily="34" charset="-122"/>
+                <a:cs typeface="Calibri" pitchFamily="34" charset="-120"/>
+              </a:rPr>
+              <a:t>Credential-expiry calendar and config-drift watch catch silent outages before they fire</a:t>
+            </a:r>
+            <a:endParaRPr lang="en-US" sz="1200" dirty="0"/>
+          </a:p>
+          <a:p>
+            <a:pPr marL="177800" indent="-177800">
+              <a:spcAft>
+                <a:spcPts val="800"/>
+              </a:spcAft>
+              <a:buSzPct val="100000"/>
+              <a:buChar char="•"/>
+            </a:pPr>
+            <a:r>
+              <a:rPr lang="en-US" sz="1200" dirty="0">
+                <a:solidFill>
+                  <a:srgbClr val="5B6577"/>
+                </a:solidFill>
+                <a:latin typeface="Calibri" pitchFamily="34" charset="0"/>
+                <a:ea typeface="Calibri" pitchFamily="34" charset="-122"/>
+                <a:cs typeface="Calibri" pitchFamily="34" charset="-120"/>
+              </a:rPr>
+              <a:t>SLA-backed: PAF/UI 99.5%, DB reachability 99.9%, MCP tool-call success ≥ 98%</a:t>
+            </a:r>
+            <a:endParaRPr lang="en-US" sz="1200" dirty="0"/>
           </a:p>
         </p:txBody>
       </p:sp>
@@ -5626,17 +5993,127 @@
         </p:nvSpPr>
         <p:spPr>
           <a:xfrm>
-            <a:off x="8193024" y="1371600"/>
-            <a:ext cx="3703320" cy="4206240"/>
+            <a:off x="457200" y="4709160"/>
+            <a:ext cx="11274552" cy="777240"/>
           </a:xfrm>
           <a:prstGeom prst="roundRect">
             <a:avLst>
-              <a:gd name="adj" fmla="val 2469"/>
+              <a:gd name="adj" fmla="val 9412"/>
             </a:avLst>
           </a:prstGeom>
           <a:solidFill>
-            <a:srgbClr val="F4F7FC"/>
-          </a:solidFill>
+            <a:srgbClr val="041F66"/>
+          </a:solidFill>
+          <a:ln/>
+        </p:spPr>
+      </p:sp>
+      <p:sp>
+        <p:nvSpPr>
+          <p:cNvPr id="20" name="Text 17"/>
+          <p:cNvSpPr/>
+          <p:nvPr/>
+        </p:nvSpPr>
+        <p:spPr>
+          <a:xfrm>
+            <a:off x="731520" y="4709160"/>
+            <a:ext cx="10698480" cy="777240"/>
+          </a:xfrm>
+          <a:prstGeom prst="rect">
+            <a:avLst/>
+          </a:prstGeom>
+          <a:noFill/>
+          <a:ln/>
+        </p:spPr>
+        <p:txBody>
+          <a:bodyPr wrap="square" rtlCol="0" anchor="ctr"/>
+          <a:lstStyle/>
+          <a:p>
+            <a:pPr indent="0" marL="0">
+              <a:buNone/>
+            </a:pPr>
+            <a:r>
+              <a:rPr lang="en-US" sz="1300" b="1" dirty="0">
+                <a:solidFill>
+                  <a:srgbClr val="1EB4E6"/>
+                </a:solidFill>
+                <a:latin typeface="Calibri" pitchFamily="34" charset="0"/>
+                <a:ea typeface="Calibri" pitchFamily="34" charset="-122"/>
+                <a:cs typeface="Calibri" pitchFamily="34" charset="-120"/>
+              </a:rPr>
+              <a:t>Ships as:  </a:t>
+            </a:r>
+            <a:pPr indent="0" marL="0">
+              <a:buNone/>
+            </a:pPr>
+            <a:r>
+              <a:rPr lang="en-US" sz="1300" dirty="0">
+                <a:solidFill>
+                  <a:srgbClr val="FFFFFF"/>
+                </a:solidFill>
+                <a:latin typeface="Calibri" pitchFamily="34" charset="0"/>
+                <a:ea typeface="Calibri" pitchFamily="34" charset="-122"/>
+                <a:cs typeface="Calibri" pitchFamily="34" charset="-120"/>
+              </a:rPr>
+              <a:t>Monitoring &amp; observability TDD (.docx)   ·   CxHub data contract (.json)   ·   Plane B probe set   ·   per-agent OAuth audit chain</a:t>
+            </a:r>
+            <a:endParaRPr lang="en-US" sz="1300" dirty="0"/>
+          </a:p>
+        </p:txBody>
+      </p:sp>
+      <p:sp>
+        <p:nvSpPr>
+          <p:cNvPr id="21" name="Text 18"/>
+          <p:cNvSpPr/>
+          <p:nvPr/>
+        </p:nvSpPr>
+        <p:spPr>
+          <a:xfrm>
+            <a:off x="457200" y="5623560"/>
+            <a:ext cx="11274552" cy="365760"/>
+          </a:xfrm>
+          <a:prstGeom prst="rect">
+            <a:avLst/>
+          </a:prstGeom>
+          <a:noFill/>
+          <a:ln/>
+        </p:spPr>
+        <p:txBody>
+          <a:bodyPr wrap="square" rtlCol="0" anchor="ctr"/>
+          <a:lstStyle/>
+          <a:p>
+            <a:pPr indent="0" marL="0">
+              <a:buNone/>
+            </a:pPr>
+            <a:r>
+              <a:rPr lang="en-US" sz="1300" i="1" dirty="0">
+                <a:solidFill>
+                  <a:srgbClr val="0632A0"/>
+                </a:solidFill>
+                <a:latin typeface="Calibri" pitchFamily="34" charset="0"/>
+                <a:ea typeface="Calibri" pitchFamily="34" charset="-122"/>
+                <a:cs typeface="Calibri" pitchFamily="34" charset="-120"/>
+              </a:rPr>
+              <a:t>Generation is the giveaway; supervision is the product — the recurring value the foundation fee funds.</a:t>
+            </a:r>
+            <a:endParaRPr lang="en-US" sz="1300" dirty="0"/>
+          </a:p>
+        </p:txBody>
+      </p:sp>
+      <p:sp>
+        <p:nvSpPr>
+          <p:cNvPr id="22" name="Shape 19"/>
+          <p:cNvSpPr/>
+          <p:nvPr/>
+        </p:nvSpPr>
+        <p:spPr>
+          <a:xfrm>
+            <a:off x="457200" y="6400800"/>
+            <a:ext cx="11277295" cy="0"/>
+          </a:xfrm>
+          <a:prstGeom prst="line">
+            <a:avLst/>
+          </a:prstGeom>
+          <a:noFill/>
           <a:ln w="12700">
             <a:solidFill>
               <a:srgbClr val="DCE4F4"/>
@@ -5647,34 +6124,14 @@
       </p:sp>
       <p:sp>
         <p:nvSpPr>
-          <p:cNvPr id="20" name="Shape 17"/>
-          <p:cNvSpPr/>
-          <p:nvPr/>
-        </p:nvSpPr>
-        <p:spPr>
-          <a:xfrm>
-            <a:off x="8193024" y="1371600"/>
-            <a:ext cx="3703320" cy="146304"/>
-          </a:xfrm>
-          <a:prstGeom prst="rect">
-            <a:avLst/>
-          </a:prstGeom>
-          <a:solidFill>
-            <a:srgbClr val="1EB4E6"/>
-          </a:solidFill>
-          <a:ln/>
-        </p:spPr>
-      </p:sp>
-      <p:sp>
-        <p:nvSpPr>
-          <p:cNvPr id="21" name="Text 18"/>
-          <p:cNvSpPr/>
-          <p:nvPr/>
-        </p:nvSpPr>
-        <p:spPr>
-          <a:xfrm>
-            <a:off x="8421624" y="1691640"/>
-            <a:ext cx="914400" cy="822960"/>
+          <p:cNvPr id="23" name="Text 20"/>
+          <p:cNvSpPr/>
+          <p:nvPr/>
+        </p:nvSpPr>
+        <p:spPr>
+          <a:xfrm>
+            <a:off x="457200" y="6437376"/>
+            <a:ext cx="7315200" cy="274320"/>
           </a:xfrm>
           <a:prstGeom prst="rect">
             <a:avLst/>
@@ -5690,85 +6147,7 @@
               <a:buNone/>
             </a:pPr>
             <a:r>
-              <a:rPr lang="en-US" sz="4400" b="1" dirty="0">
-                <a:solidFill>
-                  <a:srgbClr val="1EB4E6"/>
-                </a:solidFill>
-                <a:latin typeface="Georgia" pitchFamily="34" charset="0"/>
-                <a:ea typeface="Georgia" pitchFamily="34" charset="-122"/>
-                <a:cs typeface="Georgia" pitchFamily="34" charset="-120"/>
-              </a:rPr>
-              <a:t>3</a:t>
-            </a:r>
-            <a:endParaRPr lang="en-US" sz="4400" dirty="0"/>
-          </a:p>
-        </p:txBody>
-      </p:sp>
-      <p:sp>
-        <p:nvSpPr>
-          <p:cNvPr id="22" name="Text 19"/>
-          <p:cNvSpPr/>
-          <p:nvPr/>
-        </p:nvSpPr>
-        <p:spPr>
-          <a:xfrm>
-            <a:off x="8421624" y="2606040"/>
-            <a:ext cx="3291840" cy="640080"/>
-          </a:xfrm>
-          <a:prstGeom prst="rect">
-            <a:avLst/>
-          </a:prstGeom>
-          <a:noFill/>
-          <a:ln/>
-        </p:spPr>
-        <p:txBody>
-          <a:bodyPr wrap="square" rtlCol="0" anchor="ctr"/>
-          <a:lstStyle/>
-          <a:p>
-            <a:pPr indent="0" marL="0">
-              <a:buNone/>
-            </a:pPr>
-            <a:r>
-              <a:rPr lang="en-US" sz="1800" b="1" dirty="0">
-                <a:solidFill>
-                  <a:srgbClr val="16203A"/>
-                </a:solidFill>
-                <a:latin typeface="Georgia" pitchFamily="34" charset="0"/>
-                <a:ea typeface="Georgia" pitchFamily="34" charset="-122"/>
-                <a:cs typeface="Georgia" pitchFamily="34" charset="-120"/>
-              </a:rPr>
-              <a:t>One brand, hero graphics</a:t>
-            </a:r>
-            <a:endParaRPr lang="en-US" sz="1800" dirty="0"/>
-          </a:p>
-        </p:txBody>
-      </p:sp>
-      <p:sp>
-        <p:nvSpPr>
-          <p:cNvPr id="23" name="Text 20"/>
-          <p:cNvSpPr/>
-          <p:nvPr/>
-        </p:nvSpPr>
-        <p:spPr>
-          <a:xfrm>
-            <a:off x="8421624" y="3291840"/>
-            <a:ext cx="3246120" cy="2103120"/>
-          </a:xfrm>
-          <a:prstGeom prst="rect">
-            <a:avLst/>
-          </a:prstGeom>
-          <a:noFill/>
-          <a:ln/>
-        </p:spPr>
-        <p:txBody>
-          <a:bodyPr wrap="square" rtlCol="0" anchor="t"/>
-          <a:lstStyle/>
-          <a:p>
-            <a:pPr indent="0" marL="0">
-              <a:buNone/>
-            </a:pPr>
-            <a:r>
-              <a:rPr lang="en-US" sz="1300" dirty="0">
+              <a:rPr lang="en-US" sz="900" dirty="0">
                 <a:solidFill>
                   <a:srgbClr val="5B6577"/>
                 </a:solidFill>
@@ -5776,68 +6155,6 @@
                 <a:ea typeface="Calibri" pitchFamily="34" charset="-122"/>
                 <a:cs typeface="Calibri" pitchFamily="34" charset="-120"/>
               </a:rPr>
-              <a:t>Every artifact reads from one brand source (palette, fonts, logo, tri-color motif); hero diagrams render once and are reused across deck / design / SOW.</a:t>
-            </a:r>
-            <a:endParaRPr lang="en-US" sz="1300" dirty="0"/>
-          </a:p>
-        </p:txBody>
-      </p:sp>
-      <p:sp>
-        <p:nvSpPr>
-          <p:cNvPr id="24" name="Shape 21"/>
-          <p:cNvSpPr/>
-          <p:nvPr/>
-        </p:nvSpPr>
-        <p:spPr>
-          <a:xfrm>
-            <a:off x="457200" y="6400800"/>
-            <a:ext cx="11277295" cy="0"/>
-          </a:xfrm>
-          <a:prstGeom prst="line">
-            <a:avLst/>
-          </a:prstGeom>
-          <a:noFill/>
-          <a:ln w="12700">
-            <a:solidFill>
-              <a:srgbClr val="DCE4F4"/>
-            </a:solidFill>
-            <a:prstDash val="solid"/>
-          </a:ln>
-        </p:spPr>
-      </p:sp>
-      <p:sp>
-        <p:nvSpPr>
-          <p:cNvPr id="25" name="Text 22"/>
-          <p:cNvSpPr/>
-          <p:nvPr/>
-        </p:nvSpPr>
-        <p:spPr>
-          <a:xfrm>
-            <a:off x="457200" y="6437376"/>
-            <a:ext cx="7315200" cy="274320"/>
-          </a:xfrm>
-          <a:prstGeom prst="rect">
-            <a:avLst/>
-          </a:prstGeom>
-          <a:noFill/>
-          <a:ln/>
-        </p:spPr>
-        <p:txBody>
-          <a:bodyPr wrap="square" rtlCol="0" anchor="ctr"/>
-          <a:lstStyle/>
-          <a:p>
-            <a:pPr indent="0" marL="0">
-              <a:buNone/>
-            </a:pPr>
-            <a:r>
-              <a:rPr lang="en-US" sz="900" dirty="0">
-                <a:solidFill>
-                  <a:srgbClr val="5B6577"/>
-                </a:solidFill>
-                <a:latin typeface="Calibri" pitchFamily="34" charset="0"/>
-                <a:ea typeface="Calibri" pitchFamily="34" charset="-122"/>
-                <a:cs typeface="Calibri" pitchFamily="34" charset="-120"/>
-              </a:rPr>
               <a:t>Syntax Corporation © 2026 · Confidential</a:t>
             </a:r>
             <a:endParaRPr lang="en-US" sz="900" dirty="0"/>
@@ -5846,7 +6163,7 @@
       </p:sp>
       <p:sp>
         <p:nvSpPr>
-          <p:cNvPr id="26" name="Text 23"/>
+          <p:cNvPr id="24" name="Text 21"/>
           <p:cNvSpPr/>
           <p:nvPr/>
         </p:nvSpPr>
@@ -6028,7 +6345,7 @@
                 <a:ea typeface="Georgia" pitchFamily="34" charset="-122"/>
                 <a:cs typeface="Georgia" pitchFamily="34" charset="-120"/>
               </a:rPr>
-              <a:t>Where deliverables are created</a:t>
+              <a:t>Built right</a:t>
             </a:r>
             <a:endParaRPr lang="en-US" sz="2600" dirty="0"/>
           </a:p>
@@ -6067,7 +6384,7 @@
                 <a:ea typeface="Calibri" pitchFamily="34" charset="-122"/>
                 <a:cs typeface="Calibri" pitchFamily="34" charset="-120"/>
               </a:rPr>
-              <a:t>Reusable catalog + per-engagement artifacts</a:t>
+              <a:t>Why the deliverables are trustworthy</a:t>
             </a:r>
             <a:endParaRPr lang="en-US" sz="1300" dirty="0"/>
           </a:p>
@@ -6075,7 +6392,7 @@
       </p:sp>
       <p:pic>
         <p:nvPicPr>
-          <p:cNvPr id="8" name="Image 0" descr="/Users/mikemiller/.claude/skills/ebs-paf-agent/assets/syntax-logo.png">    </p:cNvPr>
+          <p:cNvPr id="8" name="Image 0" descr="/home/claude/skill-work/assets/syntax-logo.png">    </p:cNvPr>
           <p:cNvPicPr>
             <a:picLocks noChangeAspect="1"/>
           </p:cNvPicPr>
@@ -6106,11 +6423,11 @@
         <p:spPr>
           <a:xfrm>
             <a:off x="457200" y="1371600"/>
-            <a:ext cx="5486400" cy="4023360"/>
+            <a:ext cx="3703320" cy="4206240"/>
           </a:xfrm>
           <a:prstGeom prst="roundRect">
             <a:avLst>
-              <a:gd name="adj" fmla="val 2273"/>
+              <a:gd name="adj" fmla="val 2469"/>
             </a:avLst>
           </a:prstGeom>
           <a:solidFill>
@@ -6133,7 +6450,7 @@
         <p:spPr>
           <a:xfrm>
             <a:off x="457200" y="1371600"/>
-            <a:ext cx="5486400" cy="146304"/>
+            <a:ext cx="3703320" cy="146304"/>
           </a:xfrm>
           <a:prstGeom prst="rect">
             <a:avLst/>
@@ -6152,8 +6469,8 @@
         </p:nvSpPr>
         <p:spPr>
           <a:xfrm>
-            <a:off x="685800" y="1645920"/>
-            <a:ext cx="5029200" cy="457200"/>
+            <a:off x="685800" y="1691640"/>
+            <a:ext cx="914400" cy="822960"/>
           </a:xfrm>
           <a:prstGeom prst="rect">
             <a:avLst/>
@@ -6169,15 +6486,54 @@
               <a:buNone/>
             </a:pPr>
             <a:r>
-              <a:rPr lang="en-US" sz="1800" b="1" dirty="0">
-                <a:solidFill>
-                  <a:srgbClr val="16203A"/>
+              <a:rPr lang="en-US" sz="4400" b="1" dirty="0">
+                <a:solidFill>
+                  <a:srgbClr val="0632A0"/>
                 </a:solidFill>
                 <a:latin typeface="Georgia" pitchFamily="34" charset="0"/>
                 <a:ea typeface="Georgia" pitchFamily="34" charset="-122"/>
                 <a:cs typeface="Georgia" pitchFamily="34" charset="-120"/>
               </a:rPr>
-              <a:t>The factory (reusable)</a:t>
+              <a:t>1</a:t>
+            </a:r>
+            <a:endParaRPr lang="en-US" sz="4400" dirty="0"/>
+          </a:p>
+        </p:txBody>
+      </p:sp>
+      <p:sp>
+        <p:nvSpPr>
+          <p:cNvPr id="12" name="Text 9"/>
+          <p:cNvSpPr/>
+          <p:nvPr/>
+        </p:nvSpPr>
+        <p:spPr>
+          <a:xfrm>
+            <a:off x="685800" y="2606040"/>
+            <a:ext cx="3291840" cy="640080"/>
+          </a:xfrm>
+          <a:prstGeom prst="rect">
+            <a:avLst/>
+          </a:prstGeom>
+          <a:noFill/>
+          <a:ln/>
+        </p:spPr>
+        <p:txBody>
+          <a:bodyPr wrap="square" rtlCol="0" anchor="ctr"/>
+          <a:lstStyle/>
+          <a:p>
+            <a:pPr indent="0" marL="0">
+              <a:buNone/>
+            </a:pPr>
+            <a:r>
+              <a:rPr lang="en-US" sz="1800" b="1" dirty="0">
+                <a:solidFill>
+                  <a:srgbClr val="16203A"/>
+                </a:solidFill>
+                <a:latin typeface="Georgia" pitchFamily="34" charset="0"/>
+                <a:ea typeface="Georgia" pitchFamily="34" charset="-122"/>
+                <a:cs typeface="Georgia" pitchFamily="34" charset="-120"/>
+              </a:rPr>
+              <a:t>Single source of truth</a:t>
             </a:r>
             <a:endParaRPr lang="en-US" sz="1800" dirty="0"/>
           </a:p>
@@ -6185,14 +6541,14 @@
       </p:sp>
       <p:sp>
         <p:nvSpPr>
-          <p:cNvPr id="12" name="Text 9"/>
-          <p:cNvSpPr/>
-          <p:nvPr/>
-        </p:nvSpPr>
-        <p:spPr>
-          <a:xfrm>
-            <a:off x="685800" y="2286000"/>
-            <a:ext cx="5029200" cy="2926080"/>
+          <p:cNvPr id="13" name="Text 10"/>
+          <p:cNvSpPr/>
+          <p:nvPr/>
+        </p:nvSpPr>
+        <p:spPr>
+          <a:xfrm>
+            <a:off x="685800" y="3291840"/>
+            <a:ext cx="3246120" cy="2103120"/>
           </a:xfrm>
           <a:prstGeom prst="rect">
             <a:avLst/>
@@ -6208,106 +6564,34 @@
               <a:buNone/>
             </a:pPr>
             <a:r>
-              <a:rPr lang="en-US" sz="1400" b="1" dirty="0">
-                <a:solidFill>
-                  <a:srgbClr val="0632A0"/>
+              <a:rPr lang="en-US" sz="1300" dirty="0">
+                <a:solidFill>
+                  <a:srgbClr val="5B6577"/>
                 </a:solidFill>
                 <a:latin typeface="Calibri" pitchFamily="34" charset="0"/>
                 <a:ea typeface="Calibri" pitchFamily="34" charset="-122"/>
                 <a:cs typeface="Calibri" pitchFamily="34" charset="-120"/>
               </a:rPr>
-              <a:t>paf_claud_skill</a:t>
-            </a:r>
-            <a:endParaRPr lang="en-US" sz="1400" dirty="0"/>
-          </a:p>
-          <a:p>
-            <a:pPr marL="342900" indent="-342900">
-              <a:buSzPct val="100000"/>
-              <a:buChar char="•"/>
-            </a:pPr>
-            <a:r>
-              <a:rPr lang="en-US" sz="1200" dirty="0">
-                <a:solidFill>
-                  <a:srgbClr val="5B6577"/>
-                </a:solidFill>
-                <a:latin typeface="Calibri" pitchFamily="34" charset="0"/>
-                <a:ea typeface="Calibri" pitchFamily="34" charset="-122"/>
-                <a:cs typeface="Calibri" pitchFamily="34" charset="-120"/>
-              </a:rPr>
-              <a:t>references/deliverables.md — the recipe</a:t>
-            </a:r>
-            <a:endParaRPr lang="en-US" sz="1400" dirty="0"/>
-          </a:p>
-          <a:p>
-            <a:pPr marL="342900" indent="-342900">
-              <a:buSzPct val="100000"/>
-              <a:buChar char="•"/>
-            </a:pPr>
-            <a:r>
-              <a:rPr lang="en-US" sz="1200" dirty="0">
-                <a:solidFill>
-                  <a:srgbClr val="5B6577"/>
-                </a:solidFill>
-                <a:latin typeface="Calibri" pitchFamily="34" charset="0"/>
-                <a:ea typeface="Calibri" pitchFamily="34" charset="-122"/>
-                <a:cs typeface="Calibri" pitchFamily="34" charset="-120"/>
-              </a:rPr>
-              <a:t>deliverables/ — this catalog doc + showcase deck</a:t>
-            </a:r>
-            <a:endParaRPr lang="en-US" sz="1400" dirty="0"/>
-          </a:p>
-          <a:p>
-            <a:pPr marL="342900" indent="-342900">
-              <a:buSzPct val="100000"/>
-              <a:buChar char="•"/>
-            </a:pPr>
-            <a:r>
-              <a:rPr lang="en-US" sz="1200" dirty="0">
-                <a:solidFill>
-                  <a:srgbClr val="5B6577"/>
-                </a:solidFill>
-                <a:latin typeface="Calibri" pitchFamily="34" charset="0"/>
-                <a:ea typeface="Calibri" pitchFamily="34" charset="-122"/>
-                <a:cs typeface="Calibri" pitchFamily="34" charset="-120"/>
-              </a:rPr>
-              <a:t>templates/deliverables/ — the generators</a:t>
-            </a:r>
-            <a:endParaRPr lang="en-US" sz="1400" dirty="0"/>
-          </a:p>
-          <a:p>
-            <a:pPr marL="342900" indent="-342900">
-              <a:buSzPct val="100000"/>
-              <a:buChar char="•"/>
-            </a:pPr>
-            <a:r>
-              <a:rPr lang="en-US" sz="1200" dirty="0">
-                <a:solidFill>
-                  <a:srgbClr val="5B6577"/>
-                </a:solidFill>
-                <a:latin typeface="Calibri" pitchFamily="34" charset="0"/>
-                <a:ea typeface="Calibri" pitchFamily="34" charset="-122"/>
-                <a:cs typeface="Calibri" pitchFamily="34" charset="-120"/>
-              </a:rPr>
-              <a:t>core/ — the importable .paf + validation gate</a:t>
-            </a:r>
-            <a:endParaRPr lang="en-US" sz="1400" dirty="0"/>
-          </a:p>
-        </p:txBody>
-      </p:sp>
-      <p:sp>
-        <p:nvSpPr>
-          <p:cNvPr id="13" name="Shape 10"/>
-          <p:cNvSpPr/>
-          <p:nvPr/>
-        </p:nvSpPr>
-        <p:spPr>
-          <a:xfrm>
-            <a:off x="6217920" y="1371600"/>
-            <a:ext cx="5486400" cy="4023360"/>
+              <a:t>Customer files are generated from in-repo markdown + one pricing model. Edit the source, regenerate — deck, SOW, and ROI never disagree.</a:t>
+            </a:r>
+            <a:endParaRPr lang="en-US" sz="1300" dirty="0"/>
+          </a:p>
+        </p:txBody>
+      </p:sp>
+      <p:sp>
+        <p:nvSpPr>
+          <p:cNvPr id="14" name="Shape 11"/>
+          <p:cNvSpPr/>
+          <p:nvPr/>
+        </p:nvSpPr>
+        <p:spPr>
+          <a:xfrm>
+            <a:off x="4325112" y="1371600"/>
+            <a:ext cx="3703320" cy="4206240"/>
           </a:xfrm>
           <a:prstGeom prst="roundRect">
             <a:avLst>
-              <a:gd name="adj" fmla="val 2273"/>
+              <a:gd name="adj" fmla="val 2469"/>
             </a:avLst>
           </a:prstGeom>
           <a:solidFill>
@@ -6323,14 +6607,14 @@
       </p:sp>
       <p:sp>
         <p:nvSpPr>
-          <p:cNvPr id="14" name="Shape 11"/>
-          <p:cNvSpPr/>
-          <p:nvPr/>
-        </p:nvSpPr>
-        <p:spPr>
-          <a:xfrm>
-            <a:off x="6217920" y="1371600"/>
-            <a:ext cx="5486400" cy="146304"/>
+          <p:cNvPr id="15" name="Shape 12"/>
+          <p:cNvSpPr/>
+          <p:nvPr/>
+        </p:nvSpPr>
+        <p:spPr>
+          <a:xfrm>
+            <a:off x="4325112" y="1371600"/>
+            <a:ext cx="3703320" cy="146304"/>
           </a:xfrm>
           <a:prstGeom prst="rect">
             <a:avLst/>
@@ -6343,14 +6627,14 @@
       </p:sp>
       <p:sp>
         <p:nvSpPr>
-          <p:cNvPr id="15" name="Text 12"/>
-          <p:cNvSpPr/>
-          <p:nvPr/>
-        </p:nvSpPr>
-        <p:spPr>
-          <a:xfrm>
-            <a:off x="6446520" y="1645920"/>
-            <a:ext cx="5029200" cy="457200"/>
+          <p:cNvPr id="16" name="Text 13"/>
+          <p:cNvSpPr/>
+          <p:nvPr/>
+        </p:nvSpPr>
+        <p:spPr>
+          <a:xfrm>
+            <a:off x="4553712" y="1691640"/>
+            <a:ext cx="914400" cy="822960"/>
           </a:xfrm>
           <a:prstGeom prst="rect">
             <a:avLst/>
@@ -6366,15 +6650,54 @@
               <a:buNone/>
             </a:pPr>
             <a:r>
-              <a:rPr lang="en-US" sz="1800" b="1" dirty="0">
-                <a:solidFill>
-                  <a:srgbClr val="16203A"/>
+              <a:rPr lang="en-US" sz="4400" b="1" dirty="0">
+                <a:solidFill>
+                  <a:srgbClr val="3CC85A"/>
                 </a:solidFill>
                 <a:latin typeface="Georgia" pitchFamily="34" charset="0"/>
                 <a:ea typeface="Georgia" pitchFamily="34" charset="-122"/>
                 <a:cs typeface="Georgia" pitchFamily="34" charset="-120"/>
               </a:rPr>
-              <a:t>The engagement (the actual files)</a:t>
+              <a:t>2</a:t>
+            </a:r>
+            <a:endParaRPr lang="en-US" sz="4400" dirty="0"/>
+          </a:p>
+        </p:txBody>
+      </p:sp>
+      <p:sp>
+        <p:nvSpPr>
+          <p:cNvPr id="17" name="Text 14"/>
+          <p:cNvSpPr/>
+          <p:nvPr/>
+        </p:nvSpPr>
+        <p:spPr>
+          <a:xfrm>
+            <a:off x="4553712" y="2606040"/>
+            <a:ext cx="3291840" cy="640080"/>
+          </a:xfrm>
+          <a:prstGeom prst="rect">
+            <a:avLst/>
+          </a:prstGeom>
+          <a:noFill/>
+          <a:ln/>
+        </p:spPr>
+        <p:txBody>
+          <a:bodyPr wrap="square" rtlCol="0" anchor="ctr"/>
+          <a:lstStyle/>
+          <a:p>
+            <a:pPr indent="0" marL="0">
+              <a:buNone/>
+            </a:pPr>
+            <a:r>
+              <a:rPr lang="en-US" sz="1800" b="1" dirty="0">
+                <a:solidFill>
+                  <a:srgbClr val="16203A"/>
+                </a:solidFill>
+                <a:latin typeface="Georgia" pitchFamily="34" charset="0"/>
+                <a:ea typeface="Georgia" pitchFamily="34" charset="-122"/>
+                <a:cs typeface="Georgia" pitchFamily="34" charset="-120"/>
+              </a:rPr>
+              <a:t>QA-gated</a:t>
             </a:r>
             <a:endParaRPr lang="en-US" sz="1800" dirty="0"/>
           </a:p>
@@ -6382,14 +6705,14 @@
       </p:sp>
       <p:sp>
         <p:nvSpPr>
-          <p:cNvPr id="16" name="Text 13"/>
-          <p:cNvSpPr/>
-          <p:nvPr/>
-        </p:nvSpPr>
-        <p:spPr>
-          <a:xfrm>
-            <a:off x="6446520" y="2286000"/>
-            <a:ext cx="5029200" cy="2926080"/>
+          <p:cNvPr id="18" name="Text 15"/>
+          <p:cNvSpPr/>
+          <p:nvPr/>
+        </p:nvSpPr>
+        <p:spPr>
+          <a:xfrm>
+            <a:off x="4553712" y="3291840"/>
+            <a:ext cx="3246120" cy="2103120"/>
           </a:xfrm>
           <a:prstGeom prst="rect">
             <a:avLst/>
@@ -6405,89 +6728,39 @@
               <a:buNone/>
             </a:pPr>
             <a:r>
-              <a:rPr lang="en-US" sz="1400" b="1" dirty="0">
-                <a:solidFill>
-                  <a:srgbClr val="0632A0"/>
+              <a:rPr lang="en-US" sz="1300" dirty="0">
+                <a:solidFill>
+                  <a:srgbClr val="5B6577"/>
                 </a:solidFill>
                 <a:latin typeface="Calibri" pitchFamily="34" charset="0"/>
                 <a:ea typeface="Calibri" pitchFamily="34" charset="-122"/>
                 <a:cs typeface="Calibri" pitchFamily="34" charset="-120"/>
               </a:rPr>
-              <a:t>the agent's own git repo</a:t>
-            </a:r>
-            <a:endParaRPr lang="en-US" sz="1400" dirty="0"/>
-          </a:p>
-          <a:p>
-            <a:pPr marL="342900" indent="-342900">
-              <a:buSzPct val="100000"/>
-              <a:buChar char="•"/>
-            </a:pPr>
-            <a:r>
-              <a:rPr lang="en-US" sz="1200" dirty="0">
-                <a:solidFill>
-                  <a:srgbClr val="5B6577"/>
-                </a:solidFill>
-                <a:latin typeface="Calibri" pitchFamily="34" charset="0"/>
-                <a:ea typeface="Calibri" pitchFamily="34" charset="-122"/>
-                <a:cs typeface="Calibri" pitchFamily="34" charset="-120"/>
-              </a:rPr>
-              <a:t>deliverables/ — the .docx / .xlsx / .html / .pptx</a:t>
-            </a:r>
-            <a:endParaRPr lang="en-US" sz="1400" dirty="0"/>
-          </a:p>
-          <a:p>
-            <a:pPr marL="342900" indent="-342900">
-              <a:buSzPct val="100000"/>
-              <a:buChar char="•"/>
-            </a:pPr>
-            <a:r>
-              <a:rPr lang="en-US" sz="1200" dirty="0">
-                <a:solidFill>
-                  <a:srgbClr val="5B6577"/>
-                </a:solidFill>
-                <a:latin typeface="Calibri" pitchFamily="34" charset="0"/>
-                <a:ea typeface="Calibri" pitchFamily="34" charset="-122"/>
-                <a:cs typeface="Calibri" pitchFamily="34" charset="-120"/>
-              </a:rPr>
-              <a:t>slides/ — the deck + hero-diagram generators</a:t>
-            </a:r>
-            <a:endParaRPr lang="en-US" sz="1400" dirty="0"/>
-          </a:p>
-          <a:p>
-            <a:pPr marL="342900" indent="-342900">
-              <a:buSzPct val="100000"/>
-              <a:buChar char="•"/>
-            </a:pPr>
-            <a:r>
-              <a:rPr lang="en-US" sz="1200" i="1" dirty="0">
-                <a:solidFill>
-                  <a:srgbClr val="5B6577"/>
-                </a:solidFill>
-                <a:latin typeface="Calibri" pitchFamily="34" charset="0"/>
-                <a:ea typeface="Calibri" pitchFamily="34" charset="-122"/>
-                <a:cs typeface="Calibri" pitchFamily="34" charset="-120"/>
-              </a:rPr>
-              <a:t>e.g. EBS-Contract-Renewal-PAF (the EBS AP agent)</a:t>
-            </a:r>
-            <a:endParaRPr lang="en-US" sz="1400" dirty="0"/>
-          </a:p>
-        </p:txBody>
-      </p:sp>
-      <p:sp>
-        <p:nvSpPr>
-          <p:cNvPr id="17" name="Shape 14"/>
-          <p:cNvSpPr/>
-          <p:nvPr/>
-        </p:nvSpPr>
-        <p:spPr>
-          <a:xfrm>
-            <a:off x="457200" y="6400800"/>
-            <a:ext cx="11277295" cy="0"/>
-          </a:xfrm>
-          <a:prstGeom prst="line">
-            <a:avLst/>
-          </a:prstGeom>
-          <a:noFill/>
+              <a:t>Nothing is generated until the QA gate is green: hermetic + live + parity tests pass, and the validation gate shows zero unsafe actions.</a:t>
+            </a:r>
+            <a:endParaRPr lang="en-US" sz="1300" dirty="0"/>
+          </a:p>
+        </p:txBody>
+      </p:sp>
+      <p:sp>
+        <p:nvSpPr>
+          <p:cNvPr id="19" name="Shape 16"/>
+          <p:cNvSpPr/>
+          <p:nvPr/>
+        </p:nvSpPr>
+        <p:spPr>
+          <a:xfrm>
+            <a:off x="8193024" y="1371600"/>
+            <a:ext cx="3703320" cy="4206240"/>
+          </a:xfrm>
+          <a:prstGeom prst="roundRect">
+            <a:avLst>
+              <a:gd name="adj" fmla="val 2469"/>
+            </a:avLst>
+          </a:prstGeom>
+          <a:solidFill>
+            <a:srgbClr val="F4F7FC"/>
+          </a:solidFill>
           <a:ln w="12700">
             <a:solidFill>
               <a:srgbClr val="DCE4F4"/>
@@ -6498,14 +6771,34 @@
       </p:sp>
       <p:sp>
         <p:nvSpPr>
-          <p:cNvPr id="18" name="Text 15"/>
-          <p:cNvSpPr/>
-          <p:nvPr/>
-        </p:nvSpPr>
-        <p:spPr>
-          <a:xfrm>
-            <a:off x="457200" y="6437376"/>
-            <a:ext cx="7315200" cy="274320"/>
+          <p:cNvPr id="20" name="Shape 17"/>
+          <p:cNvSpPr/>
+          <p:nvPr/>
+        </p:nvSpPr>
+        <p:spPr>
+          <a:xfrm>
+            <a:off x="8193024" y="1371600"/>
+            <a:ext cx="3703320" cy="146304"/>
+          </a:xfrm>
+          <a:prstGeom prst="rect">
+            <a:avLst/>
+          </a:prstGeom>
+          <a:solidFill>
+            <a:srgbClr val="1EB4E6"/>
+          </a:solidFill>
+          <a:ln/>
+        </p:spPr>
+      </p:sp>
+      <p:sp>
+        <p:nvSpPr>
+          <p:cNvPr id="21" name="Text 18"/>
+          <p:cNvSpPr/>
+          <p:nvPr/>
+        </p:nvSpPr>
+        <p:spPr>
+          <a:xfrm>
+            <a:off x="8421624" y="1691640"/>
+            <a:ext cx="914400" cy="822960"/>
           </a:xfrm>
           <a:prstGeom prst="rect">
             <a:avLst/>
@@ -6521,7 +6814,85 @@
               <a:buNone/>
             </a:pPr>
             <a:r>
-              <a:rPr lang="en-US" sz="900" dirty="0">
+              <a:rPr lang="en-US" sz="4400" b="1" dirty="0">
+                <a:solidFill>
+                  <a:srgbClr val="1EB4E6"/>
+                </a:solidFill>
+                <a:latin typeface="Georgia" pitchFamily="34" charset="0"/>
+                <a:ea typeface="Georgia" pitchFamily="34" charset="-122"/>
+                <a:cs typeface="Georgia" pitchFamily="34" charset="-120"/>
+              </a:rPr>
+              <a:t>3</a:t>
+            </a:r>
+            <a:endParaRPr lang="en-US" sz="4400" dirty="0"/>
+          </a:p>
+        </p:txBody>
+      </p:sp>
+      <p:sp>
+        <p:nvSpPr>
+          <p:cNvPr id="22" name="Text 19"/>
+          <p:cNvSpPr/>
+          <p:nvPr/>
+        </p:nvSpPr>
+        <p:spPr>
+          <a:xfrm>
+            <a:off x="8421624" y="2606040"/>
+            <a:ext cx="3291840" cy="640080"/>
+          </a:xfrm>
+          <a:prstGeom prst="rect">
+            <a:avLst/>
+          </a:prstGeom>
+          <a:noFill/>
+          <a:ln/>
+        </p:spPr>
+        <p:txBody>
+          <a:bodyPr wrap="square" rtlCol="0" anchor="ctr"/>
+          <a:lstStyle/>
+          <a:p>
+            <a:pPr indent="0" marL="0">
+              <a:buNone/>
+            </a:pPr>
+            <a:r>
+              <a:rPr lang="en-US" sz="1800" b="1" dirty="0">
+                <a:solidFill>
+                  <a:srgbClr val="16203A"/>
+                </a:solidFill>
+                <a:latin typeface="Georgia" pitchFamily="34" charset="0"/>
+                <a:ea typeface="Georgia" pitchFamily="34" charset="-122"/>
+                <a:cs typeface="Georgia" pitchFamily="34" charset="-120"/>
+              </a:rPr>
+              <a:t>One brand, hero graphics</a:t>
+            </a:r>
+            <a:endParaRPr lang="en-US" sz="1800" dirty="0"/>
+          </a:p>
+        </p:txBody>
+      </p:sp>
+      <p:sp>
+        <p:nvSpPr>
+          <p:cNvPr id="23" name="Text 20"/>
+          <p:cNvSpPr/>
+          <p:nvPr/>
+        </p:nvSpPr>
+        <p:spPr>
+          <a:xfrm>
+            <a:off x="8421624" y="3291840"/>
+            <a:ext cx="3246120" cy="2103120"/>
+          </a:xfrm>
+          <a:prstGeom prst="rect">
+            <a:avLst/>
+          </a:prstGeom>
+          <a:noFill/>
+          <a:ln/>
+        </p:spPr>
+        <p:txBody>
+          <a:bodyPr wrap="square" rtlCol="0" anchor="t"/>
+          <a:lstStyle/>
+          <a:p>
+            <a:pPr indent="0" marL="0">
+              <a:buNone/>
+            </a:pPr>
+            <a:r>
+              <a:rPr lang="en-US" sz="1300" dirty="0">
                 <a:solidFill>
                   <a:srgbClr val="5B6577"/>
                 </a:solidFill>
@@ -6529,6 +6900,68 @@
                 <a:ea typeface="Calibri" pitchFamily="34" charset="-122"/>
                 <a:cs typeface="Calibri" pitchFamily="34" charset="-120"/>
               </a:rPr>
+              <a:t>Every artifact reads from one brand source (palette, fonts, logo, tri-color motif); hero diagrams render once and are reused across deck / design / SOW.</a:t>
+            </a:r>
+            <a:endParaRPr lang="en-US" sz="1300" dirty="0"/>
+          </a:p>
+        </p:txBody>
+      </p:sp>
+      <p:sp>
+        <p:nvSpPr>
+          <p:cNvPr id="24" name="Shape 21"/>
+          <p:cNvSpPr/>
+          <p:nvPr/>
+        </p:nvSpPr>
+        <p:spPr>
+          <a:xfrm>
+            <a:off x="457200" y="6400800"/>
+            <a:ext cx="11277295" cy="0"/>
+          </a:xfrm>
+          <a:prstGeom prst="line">
+            <a:avLst/>
+          </a:prstGeom>
+          <a:noFill/>
+          <a:ln w="12700">
+            <a:solidFill>
+              <a:srgbClr val="DCE4F4"/>
+            </a:solidFill>
+            <a:prstDash val="solid"/>
+          </a:ln>
+        </p:spPr>
+      </p:sp>
+      <p:sp>
+        <p:nvSpPr>
+          <p:cNvPr id="25" name="Text 22"/>
+          <p:cNvSpPr/>
+          <p:nvPr/>
+        </p:nvSpPr>
+        <p:spPr>
+          <a:xfrm>
+            <a:off x="457200" y="6437376"/>
+            <a:ext cx="7315200" cy="274320"/>
+          </a:xfrm>
+          <a:prstGeom prst="rect">
+            <a:avLst/>
+          </a:prstGeom>
+          <a:noFill/>
+          <a:ln/>
+        </p:spPr>
+        <p:txBody>
+          <a:bodyPr wrap="square" rtlCol="0" anchor="ctr"/>
+          <a:lstStyle/>
+          <a:p>
+            <a:pPr indent="0" marL="0">
+              <a:buNone/>
+            </a:pPr>
+            <a:r>
+              <a:rPr lang="en-US" sz="900" dirty="0">
+                <a:solidFill>
+                  <a:srgbClr val="5B6577"/>
+                </a:solidFill>
+                <a:latin typeface="Calibri" pitchFamily="34" charset="0"/>
+                <a:ea typeface="Calibri" pitchFamily="34" charset="-122"/>
+                <a:cs typeface="Calibri" pitchFamily="34" charset="-120"/>
+              </a:rPr>
               <a:t>Syntax Corporation © 2026 · Confidential</a:t>
             </a:r>
             <a:endParaRPr lang="en-US" sz="900" dirty="0"/>
@@ -6537,7 +6970,7 @@
       </p:sp>
       <p:sp>
         <p:nvSpPr>
-          <p:cNvPr id="19" name="Text 16"/>
+          <p:cNvPr id="26" name="Text 23"/>
           <p:cNvSpPr/>
           <p:nvPr/>
         </p:nvSpPr>
@@ -6585,6 +7018,697 @@
 <file path=ppt/slides/slide7.xml><?xml version="1.0" encoding="utf-8"?>
 <p:sld xmlns:a="http://schemas.openxmlformats.org/drawingml/2006/main" xmlns:r="http://schemas.openxmlformats.org/officeDocument/2006/relationships" xmlns:p="http://schemas.openxmlformats.org/presentationml/2006/main">
   <p:cSld name="Slide 7">
+    <p:bg>
+      <p:bgPr>
+        <a:solidFill>
+          <a:srgbClr val="FFFFFF"/>
+        </a:solidFill>
+      </p:bgPr>
+    </p:bg>
+    <p:spTree>
+      <p:nvGrpSpPr>
+        <p:cNvPr id="1" name=""/>
+        <p:cNvGrpSpPr/>
+        <p:nvPr/>
+      </p:nvGrpSpPr>
+      <p:grpSpPr>
+        <a:xfrm>
+          <a:off x="0" y="0"/>
+          <a:ext cx="0" cy="0"/>
+          <a:chOff x="0" y="0"/>
+          <a:chExt cx="0" cy="0"/>
+        </a:xfrm>
+      </p:grpSpPr>
+      <p:sp>
+        <p:nvSpPr>
+          <p:cNvPr id="2" name="Shape 0"/>
+          <p:cNvSpPr/>
+          <p:nvPr/>
+        </p:nvSpPr>
+        <p:spPr>
+          <a:xfrm>
+            <a:off x="0" y="0"/>
+            <a:ext cx="12191695" cy="960120"/>
+          </a:xfrm>
+          <a:prstGeom prst="rect">
+            <a:avLst/>
+          </a:prstGeom>
+          <a:solidFill>
+            <a:srgbClr val="041F66"/>
+          </a:solidFill>
+          <a:ln/>
+        </p:spPr>
+      </p:sp>
+      <p:sp>
+        <p:nvSpPr>
+          <p:cNvPr id="3" name="Shape 1"/>
+          <p:cNvSpPr/>
+          <p:nvPr/>
+        </p:nvSpPr>
+        <p:spPr>
+          <a:xfrm>
+            <a:off x="457200" y="384048"/>
+            <a:ext cx="310896" cy="91440"/>
+          </a:xfrm>
+          <a:prstGeom prst="rect">
+            <a:avLst/>
+          </a:prstGeom>
+          <a:solidFill>
+            <a:srgbClr val="0632A0"/>
+          </a:solidFill>
+          <a:ln/>
+        </p:spPr>
+      </p:sp>
+      <p:sp>
+        <p:nvSpPr>
+          <p:cNvPr id="4" name="Shape 2"/>
+          <p:cNvSpPr/>
+          <p:nvPr/>
+        </p:nvSpPr>
+        <p:spPr>
+          <a:xfrm>
+            <a:off x="768096" y="384048"/>
+            <a:ext cx="310896" cy="91440"/>
+          </a:xfrm>
+          <a:prstGeom prst="rect">
+            <a:avLst/>
+          </a:prstGeom>
+          <a:solidFill>
+            <a:srgbClr val="1EB4E6"/>
+          </a:solidFill>
+          <a:ln/>
+        </p:spPr>
+      </p:sp>
+      <p:sp>
+        <p:nvSpPr>
+          <p:cNvPr id="5" name="Shape 3"/>
+          <p:cNvSpPr/>
+          <p:nvPr/>
+        </p:nvSpPr>
+        <p:spPr>
+          <a:xfrm>
+            <a:off x="1078992" y="384048"/>
+            <a:ext cx="310896" cy="91440"/>
+          </a:xfrm>
+          <a:prstGeom prst="rect">
+            <a:avLst/>
+          </a:prstGeom>
+          <a:solidFill>
+            <a:srgbClr val="3CC85A"/>
+          </a:solidFill>
+          <a:ln/>
+        </p:spPr>
+      </p:sp>
+      <p:sp>
+        <p:nvSpPr>
+          <p:cNvPr id="6" name="Text 4"/>
+          <p:cNvSpPr/>
+          <p:nvPr/>
+        </p:nvSpPr>
+        <p:spPr>
+          <a:xfrm>
+            <a:off x="1554480" y="146304"/>
+            <a:ext cx="8778240" cy="457200"/>
+          </a:xfrm>
+          <a:prstGeom prst="rect">
+            <a:avLst/>
+          </a:prstGeom>
+          <a:noFill/>
+          <a:ln/>
+        </p:spPr>
+        <p:txBody>
+          <a:bodyPr wrap="square" rtlCol="0" anchor="ctr"/>
+          <a:lstStyle/>
+          <a:p>
+            <a:pPr indent="0" marL="0">
+              <a:buNone/>
+            </a:pPr>
+            <a:r>
+              <a:rPr lang="en-US" sz="2600" b="1" dirty="0">
+                <a:solidFill>
+                  <a:srgbClr val="FFFFFF"/>
+                </a:solidFill>
+                <a:latin typeface="Georgia" pitchFamily="34" charset="0"/>
+                <a:ea typeface="Georgia" pitchFamily="34" charset="-122"/>
+                <a:cs typeface="Georgia" pitchFamily="34" charset="-120"/>
+              </a:rPr>
+              <a:t>Where deliverables are created</a:t>
+            </a:r>
+            <a:endParaRPr lang="en-US" sz="2600" dirty="0"/>
+          </a:p>
+        </p:txBody>
+      </p:sp>
+      <p:sp>
+        <p:nvSpPr>
+          <p:cNvPr id="7" name="Text 5"/>
+          <p:cNvSpPr/>
+          <p:nvPr/>
+        </p:nvSpPr>
+        <p:spPr>
+          <a:xfrm>
+            <a:off x="1554480" y="566928"/>
+            <a:ext cx="10058400" cy="292608"/>
+          </a:xfrm>
+          <a:prstGeom prst="rect">
+            <a:avLst/>
+          </a:prstGeom>
+          <a:noFill/>
+          <a:ln/>
+        </p:spPr>
+        <p:txBody>
+          <a:bodyPr wrap="square" rtlCol="0" anchor="ctr"/>
+          <a:lstStyle/>
+          <a:p>
+            <a:pPr indent="0" marL="0">
+              <a:buNone/>
+            </a:pPr>
+            <a:r>
+              <a:rPr lang="en-US" sz="1300" dirty="0">
+                <a:solidFill>
+                  <a:srgbClr val="1EB4E6"/>
+                </a:solidFill>
+                <a:latin typeface="Calibri" pitchFamily="34" charset="0"/>
+                <a:ea typeface="Calibri" pitchFamily="34" charset="-122"/>
+                <a:cs typeface="Calibri" pitchFamily="34" charset="-120"/>
+              </a:rPr>
+              <a:t>Reusable catalog + per-engagement artifacts</a:t>
+            </a:r>
+            <a:endParaRPr lang="en-US" sz="1300" dirty="0"/>
+          </a:p>
+        </p:txBody>
+      </p:sp>
+      <p:pic>
+        <p:nvPicPr>
+          <p:cNvPr id="8" name="Image 0" descr="/home/claude/skill-work/assets/syntax-logo.png">    </p:cNvPr>
+          <p:cNvPicPr>
+            <a:picLocks noChangeAspect="1"/>
+          </p:cNvPicPr>
+          <p:nvPr/>
+        </p:nvPicPr>
+        <p:blipFill>
+          <a:blip r:embed="rId1"/>
+          <a:stretch>
+            <a:fillRect/>
+          </a:stretch>
+        </p:blipFill>
+        <p:spPr>
+          <a:xfrm>
+            <a:off x="10545775" y="274320"/>
+            <a:ext cx="1143000" cy="603504"/>
+          </a:xfrm>
+          <a:prstGeom prst="rect">
+            <a:avLst/>
+          </a:prstGeom>
+        </p:spPr>
+      </p:pic>
+      <p:sp>
+        <p:nvSpPr>
+          <p:cNvPr id="9" name="Shape 6"/>
+          <p:cNvSpPr/>
+          <p:nvPr/>
+        </p:nvSpPr>
+        <p:spPr>
+          <a:xfrm>
+            <a:off x="457200" y="1371600"/>
+            <a:ext cx="5486400" cy="4023360"/>
+          </a:xfrm>
+          <a:prstGeom prst="roundRect">
+            <a:avLst>
+              <a:gd name="adj" fmla="val 2273"/>
+            </a:avLst>
+          </a:prstGeom>
+          <a:solidFill>
+            <a:srgbClr val="F4F7FC"/>
+          </a:solidFill>
+          <a:ln w="12700">
+            <a:solidFill>
+              <a:srgbClr val="DCE4F4"/>
+            </a:solidFill>
+            <a:prstDash val="solid"/>
+          </a:ln>
+        </p:spPr>
+      </p:sp>
+      <p:sp>
+        <p:nvSpPr>
+          <p:cNvPr id="10" name="Shape 7"/>
+          <p:cNvSpPr/>
+          <p:nvPr/>
+        </p:nvSpPr>
+        <p:spPr>
+          <a:xfrm>
+            <a:off x="457200" y="1371600"/>
+            <a:ext cx="5486400" cy="146304"/>
+          </a:xfrm>
+          <a:prstGeom prst="rect">
+            <a:avLst/>
+          </a:prstGeom>
+          <a:solidFill>
+            <a:srgbClr val="0632A0"/>
+          </a:solidFill>
+          <a:ln/>
+        </p:spPr>
+      </p:sp>
+      <p:sp>
+        <p:nvSpPr>
+          <p:cNvPr id="11" name="Text 8"/>
+          <p:cNvSpPr/>
+          <p:nvPr/>
+        </p:nvSpPr>
+        <p:spPr>
+          <a:xfrm>
+            <a:off x="685800" y="1645920"/>
+            <a:ext cx="5029200" cy="457200"/>
+          </a:xfrm>
+          <a:prstGeom prst="rect">
+            <a:avLst/>
+          </a:prstGeom>
+          <a:noFill/>
+          <a:ln/>
+        </p:spPr>
+        <p:txBody>
+          <a:bodyPr wrap="square" rtlCol="0" anchor="ctr"/>
+          <a:lstStyle/>
+          <a:p>
+            <a:pPr indent="0" marL="0">
+              <a:buNone/>
+            </a:pPr>
+            <a:r>
+              <a:rPr lang="en-US" sz="1800" b="1" dirty="0">
+                <a:solidFill>
+                  <a:srgbClr val="16203A"/>
+                </a:solidFill>
+                <a:latin typeface="Georgia" pitchFamily="34" charset="0"/>
+                <a:ea typeface="Georgia" pitchFamily="34" charset="-122"/>
+                <a:cs typeface="Georgia" pitchFamily="34" charset="-120"/>
+              </a:rPr>
+              <a:t>The factory (reusable)</a:t>
+            </a:r>
+            <a:endParaRPr lang="en-US" sz="1800" dirty="0"/>
+          </a:p>
+        </p:txBody>
+      </p:sp>
+      <p:sp>
+        <p:nvSpPr>
+          <p:cNvPr id="12" name="Text 9"/>
+          <p:cNvSpPr/>
+          <p:nvPr/>
+        </p:nvSpPr>
+        <p:spPr>
+          <a:xfrm>
+            <a:off x="685800" y="2286000"/>
+            <a:ext cx="5029200" cy="2926080"/>
+          </a:xfrm>
+          <a:prstGeom prst="rect">
+            <a:avLst/>
+          </a:prstGeom>
+          <a:noFill/>
+          <a:ln/>
+        </p:spPr>
+        <p:txBody>
+          <a:bodyPr wrap="square" rtlCol="0" anchor="t"/>
+          <a:lstStyle/>
+          <a:p>
+            <a:pPr indent="0" marL="0">
+              <a:buNone/>
+            </a:pPr>
+            <a:r>
+              <a:rPr lang="en-US" sz="1400" b="1" dirty="0">
+                <a:solidFill>
+                  <a:srgbClr val="0632A0"/>
+                </a:solidFill>
+                <a:latin typeface="Calibri" pitchFamily="34" charset="0"/>
+                <a:ea typeface="Calibri" pitchFamily="34" charset="-122"/>
+                <a:cs typeface="Calibri" pitchFamily="34" charset="-120"/>
+              </a:rPr>
+              <a:t>paf_claud_skill</a:t>
+            </a:r>
+            <a:endParaRPr lang="en-US" sz="1400" dirty="0"/>
+          </a:p>
+          <a:p>
+            <a:pPr marL="342900" indent="-342900">
+              <a:buSzPct val="100000"/>
+              <a:buChar char="•"/>
+            </a:pPr>
+            <a:r>
+              <a:rPr lang="en-US" sz="1200" dirty="0">
+                <a:solidFill>
+                  <a:srgbClr val="5B6577"/>
+                </a:solidFill>
+                <a:latin typeface="Calibri" pitchFamily="34" charset="0"/>
+                <a:ea typeface="Calibri" pitchFamily="34" charset="-122"/>
+                <a:cs typeface="Calibri" pitchFamily="34" charset="-120"/>
+              </a:rPr>
+              <a:t>references/deliverables.md — the recipe</a:t>
+            </a:r>
+            <a:endParaRPr lang="en-US" sz="1400" dirty="0"/>
+          </a:p>
+          <a:p>
+            <a:pPr marL="342900" indent="-342900">
+              <a:buSzPct val="100000"/>
+              <a:buChar char="•"/>
+            </a:pPr>
+            <a:r>
+              <a:rPr lang="en-US" sz="1200" dirty="0">
+                <a:solidFill>
+                  <a:srgbClr val="5B6577"/>
+                </a:solidFill>
+                <a:latin typeface="Calibri" pitchFamily="34" charset="0"/>
+                <a:ea typeface="Calibri" pitchFamily="34" charset="-122"/>
+                <a:cs typeface="Calibri" pitchFamily="34" charset="-120"/>
+              </a:rPr>
+              <a:t>deliverables/ — this catalog doc + showcase deck</a:t>
+            </a:r>
+            <a:endParaRPr lang="en-US" sz="1400" dirty="0"/>
+          </a:p>
+          <a:p>
+            <a:pPr marL="342900" indent="-342900">
+              <a:buSzPct val="100000"/>
+              <a:buChar char="•"/>
+            </a:pPr>
+            <a:r>
+              <a:rPr lang="en-US" sz="1200" dirty="0">
+                <a:solidFill>
+                  <a:srgbClr val="5B6577"/>
+                </a:solidFill>
+                <a:latin typeface="Calibri" pitchFamily="34" charset="0"/>
+                <a:ea typeface="Calibri" pitchFamily="34" charset="-122"/>
+                <a:cs typeface="Calibri" pitchFamily="34" charset="-120"/>
+              </a:rPr>
+              <a:t>templates/deliverables/ — the generators</a:t>
+            </a:r>
+            <a:endParaRPr lang="en-US" sz="1400" dirty="0"/>
+          </a:p>
+          <a:p>
+            <a:pPr marL="342900" indent="-342900">
+              <a:buSzPct val="100000"/>
+              <a:buChar char="•"/>
+            </a:pPr>
+            <a:r>
+              <a:rPr lang="en-US" sz="1200" dirty="0">
+                <a:solidFill>
+                  <a:srgbClr val="5B6577"/>
+                </a:solidFill>
+                <a:latin typeface="Calibri" pitchFamily="34" charset="0"/>
+                <a:ea typeface="Calibri" pitchFamily="34" charset="-122"/>
+                <a:cs typeface="Calibri" pitchFamily="34" charset="-120"/>
+              </a:rPr>
+              <a:t>core/ — the importable .paf + validation gate</a:t>
+            </a:r>
+            <a:endParaRPr lang="en-US" sz="1400" dirty="0"/>
+          </a:p>
+        </p:txBody>
+      </p:sp>
+      <p:sp>
+        <p:nvSpPr>
+          <p:cNvPr id="13" name="Shape 10"/>
+          <p:cNvSpPr/>
+          <p:nvPr/>
+        </p:nvSpPr>
+        <p:spPr>
+          <a:xfrm>
+            <a:off x="6217920" y="1371600"/>
+            <a:ext cx="5486400" cy="4023360"/>
+          </a:xfrm>
+          <a:prstGeom prst="roundRect">
+            <a:avLst>
+              <a:gd name="adj" fmla="val 2273"/>
+            </a:avLst>
+          </a:prstGeom>
+          <a:solidFill>
+            <a:srgbClr val="F4F7FC"/>
+          </a:solidFill>
+          <a:ln w="12700">
+            <a:solidFill>
+              <a:srgbClr val="DCE4F4"/>
+            </a:solidFill>
+            <a:prstDash val="solid"/>
+          </a:ln>
+        </p:spPr>
+      </p:sp>
+      <p:sp>
+        <p:nvSpPr>
+          <p:cNvPr id="14" name="Shape 11"/>
+          <p:cNvSpPr/>
+          <p:nvPr/>
+        </p:nvSpPr>
+        <p:spPr>
+          <a:xfrm>
+            <a:off x="6217920" y="1371600"/>
+            <a:ext cx="5486400" cy="146304"/>
+          </a:xfrm>
+          <a:prstGeom prst="rect">
+            <a:avLst/>
+          </a:prstGeom>
+          <a:solidFill>
+            <a:srgbClr val="3CC85A"/>
+          </a:solidFill>
+          <a:ln/>
+        </p:spPr>
+      </p:sp>
+      <p:sp>
+        <p:nvSpPr>
+          <p:cNvPr id="15" name="Text 12"/>
+          <p:cNvSpPr/>
+          <p:nvPr/>
+        </p:nvSpPr>
+        <p:spPr>
+          <a:xfrm>
+            <a:off x="6446520" y="1645920"/>
+            <a:ext cx="5029200" cy="457200"/>
+          </a:xfrm>
+          <a:prstGeom prst="rect">
+            <a:avLst/>
+          </a:prstGeom>
+          <a:noFill/>
+          <a:ln/>
+        </p:spPr>
+        <p:txBody>
+          <a:bodyPr wrap="square" rtlCol="0" anchor="ctr"/>
+          <a:lstStyle/>
+          <a:p>
+            <a:pPr indent="0" marL="0">
+              <a:buNone/>
+            </a:pPr>
+            <a:r>
+              <a:rPr lang="en-US" sz="1800" b="1" dirty="0">
+                <a:solidFill>
+                  <a:srgbClr val="16203A"/>
+                </a:solidFill>
+                <a:latin typeface="Georgia" pitchFamily="34" charset="0"/>
+                <a:ea typeface="Georgia" pitchFamily="34" charset="-122"/>
+                <a:cs typeface="Georgia" pitchFamily="34" charset="-120"/>
+              </a:rPr>
+              <a:t>The engagement (the actual files)</a:t>
+            </a:r>
+            <a:endParaRPr lang="en-US" sz="1800" dirty="0"/>
+          </a:p>
+        </p:txBody>
+      </p:sp>
+      <p:sp>
+        <p:nvSpPr>
+          <p:cNvPr id="16" name="Text 13"/>
+          <p:cNvSpPr/>
+          <p:nvPr/>
+        </p:nvSpPr>
+        <p:spPr>
+          <a:xfrm>
+            <a:off x="6446520" y="2286000"/>
+            <a:ext cx="5029200" cy="2926080"/>
+          </a:xfrm>
+          <a:prstGeom prst="rect">
+            <a:avLst/>
+          </a:prstGeom>
+          <a:noFill/>
+          <a:ln/>
+        </p:spPr>
+        <p:txBody>
+          <a:bodyPr wrap="square" rtlCol="0" anchor="t"/>
+          <a:lstStyle/>
+          <a:p>
+            <a:pPr indent="0" marL="0">
+              <a:buNone/>
+            </a:pPr>
+            <a:r>
+              <a:rPr lang="en-US" sz="1400" b="1" dirty="0">
+                <a:solidFill>
+                  <a:srgbClr val="0632A0"/>
+                </a:solidFill>
+                <a:latin typeface="Calibri" pitchFamily="34" charset="0"/>
+                <a:ea typeface="Calibri" pitchFamily="34" charset="-122"/>
+                <a:cs typeface="Calibri" pitchFamily="34" charset="-120"/>
+              </a:rPr>
+              <a:t>the agent's own git repo</a:t>
+            </a:r>
+            <a:endParaRPr lang="en-US" sz="1400" dirty="0"/>
+          </a:p>
+          <a:p>
+            <a:pPr marL="342900" indent="-342900">
+              <a:buSzPct val="100000"/>
+              <a:buChar char="•"/>
+            </a:pPr>
+            <a:r>
+              <a:rPr lang="en-US" sz="1200" dirty="0">
+                <a:solidFill>
+                  <a:srgbClr val="5B6577"/>
+                </a:solidFill>
+                <a:latin typeface="Calibri" pitchFamily="34" charset="0"/>
+                <a:ea typeface="Calibri" pitchFamily="34" charset="-122"/>
+                <a:cs typeface="Calibri" pitchFamily="34" charset="-120"/>
+              </a:rPr>
+              <a:t>deliverables/ — the .docx / .xlsx / .html / .pptx</a:t>
+            </a:r>
+            <a:endParaRPr lang="en-US" sz="1400" dirty="0"/>
+          </a:p>
+          <a:p>
+            <a:pPr marL="342900" indent="-342900">
+              <a:buSzPct val="100000"/>
+              <a:buChar char="•"/>
+            </a:pPr>
+            <a:r>
+              <a:rPr lang="en-US" sz="1200" dirty="0">
+                <a:solidFill>
+                  <a:srgbClr val="5B6577"/>
+                </a:solidFill>
+                <a:latin typeface="Calibri" pitchFamily="34" charset="0"/>
+                <a:ea typeface="Calibri" pitchFamily="34" charset="-122"/>
+                <a:cs typeface="Calibri" pitchFamily="34" charset="-120"/>
+              </a:rPr>
+              <a:t>slides/ — the deck + hero-diagram generators</a:t>
+            </a:r>
+            <a:endParaRPr lang="en-US" sz="1400" dirty="0"/>
+          </a:p>
+          <a:p>
+            <a:pPr marL="342900" indent="-342900">
+              <a:buSzPct val="100000"/>
+              <a:buChar char="•"/>
+            </a:pPr>
+            <a:r>
+              <a:rPr lang="en-US" sz="1200" i="1" dirty="0">
+                <a:solidFill>
+                  <a:srgbClr val="5B6577"/>
+                </a:solidFill>
+                <a:latin typeface="Calibri" pitchFamily="34" charset="0"/>
+                <a:ea typeface="Calibri" pitchFamily="34" charset="-122"/>
+                <a:cs typeface="Calibri" pitchFamily="34" charset="-120"/>
+              </a:rPr>
+              <a:t>e.g. EBS-Contract-Renewal-PAF (the EBS AP agent)</a:t>
+            </a:r>
+            <a:endParaRPr lang="en-US" sz="1400" dirty="0"/>
+          </a:p>
+        </p:txBody>
+      </p:sp>
+      <p:sp>
+        <p:nvSpPr>
+          <p:cNvPr id="17" name="Shape 14"/>
+          <p:cNvSpPr/>
+          <p:nvPr/>
+        </p:nvSpPr>
+        <p:spPr>
+          <a:xfrm>
+            <a:off x="457200" y="6400800"/>
+            <a:ext cx="11277295" cy="0"/>
+          </a:xfrm>
+          <a:prstGeom prst="line">
+            <a:avLst/>
+          </a:prstGeom>
+          <a:noFill/>
+          <a:ln w="12700">
+            <a:solidFill>
+              <a:srgbClr val="DCE4F4"/>
+            </a:solidFill>
+            <a:prstDash val="solid"/>
+          </a:ln>
+        </p:spPr>
+      </p:sp>
+      <p:sp>
+        <p:nvSpPr>
+          <p:cNvPr id="18" name="Text 15"/>
+          <p:cNvSpPr/>
+          <p:nvPr/>
+        </p:nvSpPr>
+        <p:spPr>
+          <a:xfrm>
+            <a:off x="457200" y="6437376"/>
+            <a:ext cx="7315200" cy="274320"/>
+          </a:xfrm>
+          <a:prstGeom prst="rect">
+            <a:avLst/>
+          </a:prstGeom>
+          <a:noFill/>
+          <a:ln/>
+        </p:spPr>
+        <p:txBody>
+          <a:bodyPr wrap="square" rtlCol="0" anchor="ctr"/>
+          <a:lstStyle/>
+          <a:p>
+            <a:pPr indent="0" marL="0">
+              <a:buNone/>
+            </a:pPr>
+            <a:r>
+              <a:rPr lang="en-US" sz="900" dirty="0">
+                <a:solidFill>
+                  <a:srgbClr val="5B6577"/>
+                </a:solidFill>
+                <a:latin typeface="Calibri" pitchFamily="34" charset="0"/>
+                <a:ea typeface="Calibri" pitchFamily="34" charset="-122"/>
+                <a:cs typeface="Calibri" pitchFamily="34" charset="-120"/>
+              </a:rPr>
+              <a:t>Syntax Corporation © 2026 · Confidential</a:t>
+            </a:r>
+            <a:endParaRPr lang="en-US" sz="900" dirty="0"/>
+          </a:p>
+        </p:txBody>
+      </p:sp>
+      <p:sp>
+        <p:nvSpPr>
+          <p:cNvPr id="19" name="Text 16"/>
+          <p:cNvSpPr/>
+          <p:nvPr/>
+        </p:nvSpPr>
+        <p:spPr>
+          <a:xfrm>
+            <a:off x="11277295" y="6437376"/>
+            <a:ext cx="457200" cy="274320"/>
+          </a:xfrm>
+          <a:prstGeom prst="rect">
+            <a:avLst/>
+          </a:prstGeom>
+          <a:noFill/>
+          <a:ln/>
+        </p:spPr>
+        <p:txBody>
+          <a:bodyPr wrap="square" rtlCol="0" anchor="ctr"/>
+          <a:lstStyle/>
+          <a:p>
+            <a:pPr algn="r" indent="0" marL="0">
+              <a:buNone/>
+            </a:pPr>
+            <a:r>
+              <a:rPr lang="en-US" sz="900" dirty="0">
+                <a:solidFill>
+                  <a:srgbClr val="5B6577"/>
+                </a:solidFill>
+                <a:latin typeface="Calibri" pitchFamily="34" charset="0"/>
+                <a:ea typeface="Calibri" pitchFamily="34" charset="-122"/>
+                <a:cs typeface="Calibri" pitchFamily="34" charset="-120"/>
+              </a:rPr>
+              <a:t>7</a:t>
+            </a:r>
+            <a:endParaRPr lang="en-US" sz="900" dirty="0"/>
+          </a:p>
+        </p:txBody>
+      </p:sp>
+    </p:spTree>
+  </p:cSld>
+  <p:clrMapOvr>
+    <a:masterClrMapping/>
+  </p:clrMapOvr>
+</p:sld>
+</file>
+
+<file path=ppt/slides/slide8.xml><?xml version="1.0" encoding="utf-8"?>
+<p:sld xmlns:a="http://schemas.openxmlformats.org/drawingml/2006/main" xmlns:r="http://schemas.openxmlformats.org/officeDocument/2006/relationships" xmlns:p="http://schemas.openxmlformats.org/presentationml/2006/main">
+  <p:cSld name="Slide 8">
     <p:bg>
       <p:bgPr>
         <a:solidFill>
@@ -6746,7 +7870,7 @@
       </p:sp>
       <p:pic>
         <p:nvPicPr>
-          <p:cNvPr id="7" name="Image 0" descr="/Users/mikemiller/.claude/skills/ebs-paf-agent/assets/syntax-logo.png">    </p:cNvPr>
+          <p:cNvPr id="7" name="Image 0" descr="/home/claude/skill-work/assets/syntax-logo.png">    </p:cNvPr>
           <p:cNvPicPr>
             <a:picLocks noChangeAspect="1"/>
           </p:cNvPicPr>

</xml_diff>